<commit_message>
docs(presentation): slide 8 shows measured information gain, not hand-set numbers
The information-gain card now reports the outcome-model pilot: the three
target-only lookups the system runs today carry about 0 bits, while
animal-model (38% vs 17%) and human genetic evidence (35% vs 17%) on the
target-disease pair separate approved targets from efficacy failures, in
line with Minikel et al., Nature 2024. The GLP-1 walk-through, whose
numbers came from the hand-set tables, is removed. The slide says the
system still queries by target, adds one line on generality, and slide 11
lists target-disease lookups as a next step.

Co-Authored-By: Claude Opus 5.5 <noreply@anthropic.com>
Claude-Session: https://claude.ai/code/session_01N3eKUYEMW9nNyqsgHAmDB9
</commit_message>
<xml_diff>
--- a/docs/presentation/MedScience-3.0-设计汇报.pptx
+++ b/docs/presentation/MedScience-3.0-设计汇报.pptx
@@ -117,18 +117,18 @@
   <p:extLst>
     <p:ext uri="{521415D9-36F7-43E2-AB2F-B90AF26B5E84}">
       <p14:sectionLst xmlns:p14="http://schemas.microsoft.com/office/powerpoint/2010/main">
-        <p14:section name="开篇" id="{acb74e37-9c4e-7c4f-c908-bac3683bfd3d}">
+        <p14:section name="开篇" id="{3344a67d-bd4a-7f3b-5340-2f0a79df02d5}">
           <p14:sldIdLst>
             <p14:sldId id="256"/>
           </p14:sldIdLst>
         </p14:section>
-        <p14:section name="为什么" id="{b1d40a9f-efc3-837c-6c94-e791f2897bfb}">
+        <p14:section name="为什么" id="{6e04994c-9219-a7e8-dfb3-f7ddfd875bfd}">
           <p14:sldIdLst>
             <p14:sldId id="257"/>
             <p14:sldId id="258"/>
           </p14:sldIdLst>
         </p14:section>
-        <p14:section name="怎么设计" id="{51d15244-e086-9867-c2ec-c2686594f1a6}">
+        <p14:section name="怎么设计" id="{2f1c2109-ddf4-2d16-c4b2-19ed87b4fb3b}">
           <p14:sldIdLst>
             <p14:sldId id="259"/>
             <p14:sldId id="260"/>
@@ -138,12 +138,12 @@
             <p14:sldId id="264"/>
           </p14:sldIdLst>
         </p14:section>
-        <p14:section name="怎么用" id="{028fb603-29a9-7cd6-c483-2ce86833ef5c}">
+        <p14:section name="怎么用" id="{8e09d48f-5af5-0287-e113-fcf3a9978b9a}">
           <p14:sldIdLst>
             <p14:sldId id="265"/>
           </p14:sldIdLst>
         </p14:section>
-        <p14:section name="下一步" id="{00ddf30f-863a-08a1-7a12-cb7de6a2ec62}">
+        <p14:section name="下一步" id="{10669b09-44b0-5cfd-4397-7738921c832d}">
           <p14:sldIdLst>
             <p14:sldId id="266"/>
           </p14:sldIdLst>
@@ -728,7 +728,7 @@
           <a:p>
             <a:r>
               <a:rPr lang="en-US" dirty="0"/>
-              <a:t>最后是进展和请求。设计已全部落地并发布，可以下载试用；尚待验证的是有效性。最需要的支持是领域专家标注一批真实假设，用于校准和评测，然后做同等预算的对照实验，结果稳定后发布正式版并整理论文。</a:t>
+              <a:t>最后是进展和请求。设计已全部落地并发布，可以下载试用；尚待验证的是有效性。最需要的支持是领域专家标注一批真实假设，用于校准和评测，然后做同等预算的对照实验；同时把查询改为按“靶点–疾病”进行，优先取遗传学和动物模型证据，这一点已有实测数据支持。结果稳定后发布正式版并整理论文。</a:t>
             </a:r>
             <a:endParaRPr lang="en-US" dirty="0"/>
           </a:p>
@@ -1344,7 +1344,7 @@
           <a:p>
             <a:r>
               <a:rPr lang="en-US" dirty="0"/>
-              <a:t>左边是信息增益取证。先用类比：医生分辨流感和感冒，量体温没用，因为两种病都发烧；流感抗原检测结果差别大，所以先做。信息增益就是给每项查询“能把两种可能分开多少”打分。例子是“GLP-1 受体激动剂可用于减重”，起点五五开。看表格：查靶点序列，假设成立时 95% 能查到，不成立时也有 80%，差别很小，相当于量体温；查强活性药物，成立时 60%、不成立时只有 10%，差别最大，所以先查。实际过程：查到司美格鲁肽对 GLP-1 受体亲和力 0.38 纳摩尔，支持概率从 0.50 升到 0.86；再查到三期试验 STEP 1，升到 0.95，分歧度从 1.0 降到 0.28。技术上，分歧度是当前判断的熵除以最大熵，信息增益是查询前的熵减去查询后平均剩余的熵，单位是比特；概率表目前是人工设定的先验，正式实验前要用标注数据估计，所以第一步的增益与具体药物无关。右边是共形三分判定：用一批已知结果的历史假设校准，结论以“可能成立的结果集合”给出，集合里只有一个答案才下结论；两个都可能就是证据不足。校准后错误率有统计保证，没校准时系统会明确说明。</a:t>
+              <a:t>左边是信息增益取证。先用类比：量体温分不开流感和感冒，抗原检测才分得开；信息增益就是给每项查询“能把有效和无效分开多少”打分。原来的概率表是人工设定的，我们用真实数据做了实测：一组是已有获批药物的靶点，一组是药物因疗效不足在二、三期试验中失败、至今没有获批药物的靶点。结果是，只看靶点本身的三种查询——查序列、查临床试验、查化合物活性——两组几乎一样，信息增益接近 0。原因不难理解：能走到二、三期的靶点本来就都有强效化合物，活性说明能不能成药，不说明有没有效。看靶点和这个疾病之间的关系就不一样了：有动物模型证据的比例是 38% 对 17%，有人类遗传学证据的是 35% 对 17%，这和 Nature 2024 的结论一致，有遗传学支持的药物机制成功率高 2.6 倍。所以改进方向是把查询从“按靶点”改成“按靶点和疾病”。需要说明两点：第一，样本还小，动物模型差异显著，遗传学接近显著；第二，系统目前还是按靶点查询，这项改进放在下一版。关于普适性：计算方法是通用的，但概率表和具体该查什么，随问题类型而定；换一类问题，比如生物标志物的诊断价值，需要用这一类已知答案的案例重新实测一次，流程和代码不变。右边是共形三分判定：用一批已知结果的历史假设校准，结论以“可能成立的结果集合”给出，集合里只有一个答案才下结论；两个都可能就是证据不足。校准后错误率有统计保证，没校准时系统会明确说明。</a:t>
             </a:r>
             <a:endParaRPr lang="en-US" dirty="0"/>
           </a:p>
@@ -2415,7 +2415,7 @@
       </p:sp>
       <p:sp>
         <p:nvSpPr>
-          <p:cNvPr id="4" name="label-232"/>
+          <p:cNvPr id="4" name="label-239"/>
           <p:cNvSpPr txBox="1"/>
           <p:nvPr/>
         </p:nvSpPr>
@@ -2451,7 +2451,7 @@
       </p:sp>
       <p:sp>
         <p:nvSpPr>
-          <p:cNvPr id="5" name="badge-233"/>
+          <p:cNvPr id="5" name="badge-240"/>
           <p:cNvSpPr/>
           <p:nvPr/>
         </p:nvSpPr>
@@ -2493,7 +2493,7 @@
       </p:sp>
       <p:sp>
         <p:nvSpPr>
-          <p:cNvPr id="6" name="label-234"/>
+          <p:cNvPr id="6" name="label-241"/>
           <p:cNvSpPr txBox="1"/>
           <p:nvPr/>
         </p:nvSpPr>
@@ -2529,7 +2529,7 @@
       </p:sp>
       <p:sp>
         <p:nvSpPr>
-          <p:cNvPr id="7" name="label-235"/>
+          <p:cNvPr id="7" name="label-242"/>
           <p:cNvSpPr txBox="1"/>
           <p:nvPr/>
         </p:nvSpPr>
@@ -2565,7 +2565,7 @@
       </p:sp>
       <p:sp>
         <p:nvSpPr>
-          <p:cNvPr id="8" name="badge-236"/>
+          <p:cNvPr id="8" name="badge-243"/>
           <p:cNvSpPr/>
           <p:nvPr/>
         </p:nvSpPr>
@@ -2607,7 +2607,7 @@
       </p:sp>
       <p:sp>
         <p:nvSpPr>
-          <p:cNvPr id="9" name="label-237"/>
+          <p:cNvPr id="9" name="label-244"/>
           <p:cNvSpPr txBox="1"/>
           <p:nvPr/>
         </p:nvSpPr>
@@ -2643,7 +2643,7 @@
       </p:sp>
       <p:sp>
         <p:nvSpPr>
-          <p:cNvPr id="10" name="label-238"/>
+          <p:cNvPr id="10" name="label-245"/>
           <p:cNvSpPr txBox="1"/>
           <p:nvPr/>
         </p:nvSpPr>
@@ -2679,7 +2679,7 @@
       </p:sp>
       <p:sp>
         <p:nvSpPr>
-          <p:cNvPr id="11" name="badge-239"/>
+          <p:cNvPr id="11" name="badge-246"/>
           <p:cNvSpPr/>
           <p:nvPr/>
         </p:nvSpPr>
@@ -2721,7 +2721,7 @@
       </p:sp>
       <p:sp>
         <p:nvSpPr>
-          <p:cNvPr id="12" name="label-240"/>
+          <p:cNvPr id="12" name="label-247"/>
           <p:cNvSpPr txBox="1"/>
           <p:nvPr/>
         </p:nvSpPr>
@@ -2757,7 +2757,7 @@
       </p:sp>
       <p:sp>
         <p:nvSpPr>
-          <p:cNvPr id="13" name="label-241"/>
+          <p:cNvPr id="13" name="label-248"/>
           <p:cNvSpPr txBox="1"/>
           <p:nvPr/>
         </p:nvSpPr>
@@ -2793,7 +2793,7 @@
       </p:sp>
       <p:pic>
         <p:nvPicPr>
-          <p:cNvPr id="14" name="screenshot-242" descr="自动检测到本机的 Claude Code">    </p:cNvPr>
+          <p:cNvPr id="14" name="screenshot-249" descr="自动检测到本机的 Claude Code">    </p:cNvPr>
           <p:cNvPicPr>
             <a:picLocks noChangeAspect="1"/>
           </p:cNvPicPr>
@@ -2817,7 +2817,7 @@
       </p:pic>
       <p:sp>
         <p:nvSpPr>
-          <p:cNvPr id="15" name="frame-243"/>
+          <p:cNvPr id="15" name="frame-250"/>
           <p:cNvSpPr/>
           <p:nvPr/>
         </p:nvSpPr>
@@ -2844,7 +2844,7 @@
       </p:sp>
       <p:sp>
         <p:nvSpPr>
-          <p:cNvPr id="16" name="label-244"/>
+          <p:cNvPr id="16" name="label-251"/>
           <p:cNvSpPr txBox="1"/>
           <p:nvPr/>
         </p:nvSpPr>
@@ -2880,7 +2880,7 @@
       </p:sp>
       <p:pic>
         <p:nvPicPr>
-          <p:cNvPr id="17" name="screenshot-245" descr="usage-ask-mention.jpg">    </p:cNvPr>
+          <p:cNvPr id="17" name="screenshot-252" descr="usage-ask-mention.jpg">    </p:cNvPr>
           <p:cNvPicPr>
             <a:picLocks noChangeAspect="1"/>
           </p:cNvPicPr>
@@ -2904,7 +2904,7 @@
       </p:pic>
       <p:sp>
         <p:nvSpPr>
-          <p:cNvPr id="18" name="frame-246"/>
+          <p:cNvPr id="18" name="frame-253"/>
           <p:cNvSpPr/>
           <p:nvPr/>
         </p:nvSpPr>
@@ -2931,7 +2931,7 @@
       </p:sp>
       <p:pic>
         <p:nvPicPr>
-          <p:cNvPr id="19" name="screenshot-247" descr="@ 点名专家；工具调用逐步可查">    </p:cNvPr>
+          <p:cNvPr id="19" name="screenshot-254" descr="@ 点名专家；工具调用逐步可查">    </p:cNvPr>
           <p:cNvPicPr>
             <a:picLocks noChangeAspect="1"/>
           </p:cNvPicPr>
@@ -2955,7 +2955,7 @@
       </p:pic>
       <p:sp>
         <p:nvSpPr>
-          <p:cNvPr id="20" name="frame-248"/>
+          <p:cNvPr id="20" name="frame-255"/>
           <p:cNvSpPr/>
           <p:nvPr/>
         </p:nvSpPr>
@@ -2982,7 +2982,7 @@
       </p:sp>
       <p:sp>
         <p:nvSpPr>
-          <p:cNvPr id="21" name="label-249"/>
+          <p:cNvPr id="21" name="label-256"/>
           <p:cNvSpPr txBox="1"/>
           <p:nvPr/>
         </p:nvSpPr>
@@ -3018,7 +3018,7 @@
       </p:sp>
       <p:pic>
         <p:nvPicPr>
-          <p:cNvPr id="22" name="screenshot-250" descr="证据账本：状态、来源、完整历史">    </p:cNvPr>
+          <p:cNvPr id="22" name="screenshot-257" descr="证据账本：状态、来源、完整历史">    </p:cNvPr>
           <p:cNvPicPr>
             <a:picLocks noChangeAspect="1"/>
           </p:cNvPicPr>
@@ -3042,7 +3042,7 @@
       </p:pic>
       <p:sp>
         <p:nvSpPr>
-          <p:cNvPr id="23" name="frame-251"/>
+          <p:cNvPr id="23" name="frame-258"/>
           <p:cNvSpPr/>
           <p:nvPr/>
         </p:nvSpPr>
@@ -3069,7 +3069,7 @@
       </p:sp>
       <p:sp>
         <p:nvSpPr>
-          <p:cNvPr id="24" name="label-252"/>
+          <p:cNvPr id="24" name="label-259"/>
           <p:cNvSpPr txBox="1"/>
           <p:nvPr/>
         </p:nvSpPr>
@@ -3105,7 +3105,7 @@
       </p:sp>
       <p:sp>
         <p:nvSpPr>
-          <p:cNvPr id="25" name="label-253"/>
+          <p:cNvPr id="25" name="label-260"/>
           <p:cNvSpPr txBox="1"/>
           <p:nvPr/>
         </p:nvSpPr>
@@ -3287,7 +3287,7 @@
       </p:sp>
       <p:sp>
         <p:nvSpPr>
-          <p:cNvPr id="4" name="card-254"/>
+          <p:cNvPr id="4" name="card-261"/>
           <p:cNvSpPr/>
           <p:nvPr/>
         </p:nvSpPr>
@@ -3314,7 +3314,7 @@
       </p:sp>
       <p:sp>
         <p:nvSpPr>
-          <p:cNvPr id="5" name="badge-255"/>
+          <p:cNvPr id="5" name="badge-262"/>
           <p:cNvSpPr/>
           <p:nvPr/>
         </p:nvSpPr>
@@ -3356,7 +3356,7 @@
       </p:sp>
       <p:sp>
         <p:nvSpPr>
-          <p:cNvPr id="6" name="label-256"/>
+          <p:cNvPr id="6" name="label-263"/>
           <p:cNvSpPr txBox="1"/>
           <p:nvPr/>
         </p:nvSpPr>
@@ -3392,14 +3392,14 @@
       </p:sp>
       <p:sp>
         <p:nvSpPr>
-          <p:cNvPr id="7" name="bullets-257"/>
+          <p:cNvPr id="7" name="bullets-264"/>
           <p:cNvSpPr txBox="1"/>
           <p:nvPr/>
         </p:nvSpPr>
         <p:spPr>
           <a:xfrm>
             <a:off x="822960" y="2514600"/>
-            <a:ext cx="3012338" cy="2926080"/>
+            <a:ext cx="3012338" cy="2971800"/>
           </a:xfrm>
           <a:prstGeom prst="rect">
             <a:avLst/>
@@ -3413,80 +3413,80 @@
           <a:p>
             <a:pPr marL="177800" indent="-177800">
               <a:spcAft>
-                <a:spcPts val="1200"/>
+                <a:spcPts val="900"/>
               </a:spcAft>
               <a:buSzPct val="100000"/>
               <a:buChar char="•"/>
             </a:pPr>
             <a:r>
-              <a:rPr lang="en-US" sz="1500" dirty="0">
+              <a:rPr lang="en-US" sz="1400" dirty="0">
                 <a:solidFill>
                   <a:schemeClr val="tx1"/>
                 </a:solidFill>
               </a:rPr>
               <a:t>v3.0.0 已发布：macOS、Windows、Linux 安装包和本地 Web 版</a:t>
             </a:r>
-            <a:endParaRPr lang="en-US" sz="1500" dirty="0"/>
+            <a:endParaRPr lang="en-US" sz="1400" dirty="0"/>
           </a:p>
           <a:p>
             <a:pPr marL="177800" indent="-177800">
               <a:spcAft>
-                <a:spcPts val="1200"/>
+                <a:spcPts val="900"/>
               </a:spcAft>
               <a:buSzPct val="100000"/>
               <a:buChar char="•"/>
             </a:pPr>
             <a:r>
-              <a:rPr lang="en-US" sz="1500" dirty="0">
+              <a:rPr lang="en-US" sz="1400" dirty="0">
                 <a:solidFill>
                   <a:schemeClr val="tx1"/>
                 </a:solidFill>
               </a:rPr>
               <a:t>三类设计全部落地，并接入桌面端界面</a:t>
             </a:r>
-            <a:endParaRPr lang="en-US" sz="1500" dirty="0"/>
+            <a:endParaRPr lang="en-US" sz="1400" dirty="0"/>
           </a:p>
           <a:p>
             <a:pPr marL="177800" indent="-177800">
               <a:spcAft>
-                <a:spcPts val="1200"/>
+                <a:spcPts val="900"/>
               </a:spcAft>
               <a:buSzPct val="100000"/>
               <a:buChar char="•"/>
             </a:pPr>
             <a:r>
-              <a:rPr lang="en-US" sz="1500" dirty="0">
+              <a:rPr lang="en-US" sz="1400" dirty="0">
                 <a:solidFill>
                   <a:schemeClr val="tx1"/>
                 </a:solidFill>
               </a:rPr>
               <a:t>自动化测试在三个平台持续通过</a:t>
             </a:r>
-            <a:endParaRPr lang="en-US" sz="1500" dirty="0"/>
+            <a:endParaRPr lang="en-US" sz="1400" dirty="0"/>
           </a:p>
           <a:p>
             <a:pPr marL="177800" indent="-177800">
               <a:spcAft>
-                <a:spcPts val="1200"/>
+                <a:spcPts val="900"/>
               </a:spcAft>
               <a:buSzPct val="100000"/>
               <a:buChar char="•"/>
             </a:pPr>
             <a:r>
-              <a:rPr lang="en-US" sz="1500" dirty="0">
+              <a:rPr lang="en-US" sz="1400" dirty="0">
                 <a:solidFill>
                   <a:schemeClr val="tx1"/>
                 </a:solidFill>
               </a:rPr>
               <a:t>评分只看证据，不再受靶点名称影响</a:t>
             </a:r>
-            <a:endParaRPr lang="en-US" sz="1500" dirty="0"/>
-          </a:p>
-        </p:txBody>
-      </p:sp>
-      <p:sp>
-        <p:nvSpPr>
-          <p:cNvPr id="8" name="card-258"/>
+            <a:endParaRPr lang="en-US" sz="1400" dirty="0"/>
+          </a:p>
+        </p:txBody>
+      </p:sp>
+      <p:sp>
+        <p:nvSpPr>
+          <p:cNvPr id="8" name="card-265"/>
           <p:cNvSpPr/>
           <p:nvPr/>
         </p:nvSpPr>
@@ -3513,7 +3513,7 @@
       </p:sp>
       <p:sp>
         <p:nvSpPr>
-          <p:cNvPr id="9" name="badge-259"/>
+          <p:cNvPr id="9" name="badge-266"/>
           <p:cNvSpPr/>
           <p:nvPr/>
         </p:nvSpPr>
@@ -3555,7 +3555,7 @@
       </p:sp>
       <p:sp>
         <p:nvSpPr>
-          <p:cNvPr id="10" name="label-260"/>
+          <p:cNvPr id="10" name="label-267"/>
           <p:cNvSpPr txBox="1"/>
           <p:nvPr/>
         </p:nvSpPr>
@@ -3591,14 +3591,14 @@
       </p:sp>
       <p:sp>
         <p:nvSpPr>
-          <p:cNvPr id="11" name="bullets-261"/>
+          <p:cNvPr id="11" name="bullets-268"/>
           <p:cNvSpPr txBox="1"/>
           <p:nvPr/>
         </p:nvSpPr>
         <p:spPr>
           <a:xfrm>
             <a:off x="4612538" y="2514600"/>
-            <a:ext cx="3012338" cy="2926080"/>
+            <a:ext cx="3012338" cy="2971800"/>
           </a:xfrm>
           <a:prstGeom prst="rect">
             <a:avLst/>
@@ -3612,62 +3612,62 @@
           <a:p>
             <a:pPr marL="177800" indent="-177800">
               <a:spcAft>
-                <a:spcPts val="1200"/>
+                <a:spcPts val="900"/>
               </a:spcAft>
               <a:buSzPct val="100000"/>
               <a:buChar char="•"/>
             </a:pPr>
             <a:r>
-              <a:rPr lang="en-US" sz="1500" dirty="0">
+              <a:rPr lang="en-US" sz="1400" dirty="0">
                 <a:solidFill>
                   <a:schemeClr val="tx1"/>
                 </a:solidFill>
               </a:rPr>
               <a:t>尚未在真实科研任务上做对照实验</a:t>
             </a:r>
-            <a:endParaRPr lang="en-US" sz="1500" dirty="0"/>
+            <a:endParaRPr lang="en-US" sz="1400" dirty="0"/>
           </a:p>
           <a:p>
             <a:pPr marL="177800" indent="-177800">
               <a:spcAft>
-                <a:spcPts val="1200"/>
+                <a:spcPts val="900"/>
               </a:spcAft>
               <a:buSzPct val="100000"/>
               <a:buChar char="•"/>
             </a:pPr>
             <a:r>
-              <a:rPr lang="en-US" sz="1500" dirty="0">
+              <a:rPr lang="en-US" sz="1400" dirty="0">
                 <a:solidFill>
                   <a:schemeClr val="tx1"/>
                 </a:solidFill>
               </a:rPr>
               <a:t>判定目前处于“未校准”状态，尚无覆盖率保证</a:t>
             </a:r>
-            <a:endParaRPr lang="en-US" sz="1500" dirty="0"/>
+            <a:endParaRPr lang="en-US" sz="1400" dirty="0"/>
           </a:p>
           <a:p>
             <a:pPr marL="177800" indent="-177800">
               <a:spcAft>
-                <a:spcPts val="1200"/>
+                <a:spcPts val="900"/>
               </a:spcAft>
               <a:buSzPct val="100000"/>
               <a:buChar char="•"/>
             </a:pPr>
             <a:r>
-              <a:rPr lang="en-US" sz="1500" dirty="0">
+              <a:rPr lang="en-US" sz="1400" dirty="0">
                 <a:solidFill>
                   <a:schemeClr val="tx1"/>
                 </a:solidFill>
               </a:rPr>
               <a:t>部分本地命令行工具仅为通用接入，待逐一验证</a:t>
             </a:r>
-            <a:endParaRPr lang="en-US" sz="1500" dirty="0"/>
-          </a:p>
-        </p:txBody>
-      </p:sp>
-      <p:sp>
-        <p:nvSpPr>
-          <p:cNvPr id="12" name="card-262"/>
+            <a:endParaRPr lang="en-US" sz="1400" dirty="0"/>
+          </a:p>
+        </p:txBody>
+      </p:sp>
+      <p:sp>
+        <p:nvSpPr>
+          <p:cNvPr id="12" name="card-269"/>
           <p:cNvSpPr/>
           <p:nvPr/>
         </p:nvSpPr>
@@ -3694,7 +3694,7 @@
       </p:sp>
       <p:sp>
         <p:nvSpPr>
-          <p:cNvPr id="13" name="badge-263"/>
+          <p:cNvPr id="13" name="badge-270"/>
           <p:cNvSpPr/>
           <p:nvPr/>
         </p:nvSpPr>
@@ -3736,7 +3736,7 @@
       </p:sp>
       <p:sp>
         <p:nvSpPr>
-          <p:cNvPr id="14" name="label-264"/>
+          <p:cNvPr id="14" name="label-271"/>
           <p:cNvSpPr txBox="1"/>
           <p:nvPr/>
         </p:nvSpPr>
@@ -3772,14 +3772,14 @@
       </p:sp>
       <p:sp>
         <p:nvSpPr>
-          <p:cNvPr id="15" name="bullets-265"/>
+          <p:cNvPr id="15" name="bullets-272"/>
           <p:cNvSpPr txBox="1"/>
           <p:nvPr/>
         </p:nvSpPr>
         <p:spPr>
           <a:xfrm>
             <a:off x="8402117" y="2514600"/>
-            <a:ext cx="3012338" cy="2926080"/>
+            <a:ext cx="3012338" cy="2971800"/>
           </a:xfrm>
           <a:prstGeom prst="rect">
             <a:avLst/>
@@ -3793,62 +3793,80 @@
           <a:p>
             <a:pPr marL="177800" indent="-177800">
               <a:spcAft>
-                <a:spcPts val="1200"/>
+                <a:spcPts val="900"/>
               </a:spcAft>
               <a:buSzPct val="100000"/>
               <a:buChar char="•"/>
             </a:pPr>
             <a:r>
-              <a:rPr lang="en-US" sz="1500" dirty="0">
+              <a:rPr lang="en-US" sz="1400" dirty="0">
                 <a:solidFill>
                   <a:schemeClr val="tx1"/>
                 </a:solidFill>
               </a:rPr>
               <a:t>组织领域专家标注一批真实假设（支持 / 反驳），用于校准与评测</a:t>
             </a:r>
-            <a:endParaRPr lang="en-US" sz="1500" dirty="0"/>
+            <a:endParaRPr lang="en-US" sz="1400" dirty="0"/>
           </a:p>
           <a:p>
             <a:pPr marL="177800" indent="-177800">
               <a:spcAft>
-                <a:spcPts val="1200"/>
+                <a:spcPts val="900"/>
               </a:spcAft>
               <a:buSzPct val="100000"/>
               <a:buChar char="•"/>
             </a:pPr>
             <a:r>
-              <a:rPr lang="en-US" sz="1500" dirty="0">
+              <a:rPr lang="en-US" sz="1400" dirty="0">
                 <a:solidFill>
                   <a:schemeClr val="tx1"/>
                 </a:solidFill>
               </a:rPr>
               <a:t>开展同等预算的对照实验：与扁平记忆、多智能体辩论比较</a:t>
             </a:r>
-            <a:endParaRPr lang="en-US" sz="1500" dirty="0"/>
+            <a:endParaRPr lang="en-US" sz="1400" dirty="0"/>
           </a:p>
           <a:p>
             <a:pPr marL="177800" indent="-177800">
               <a:spcAft>
-                <a:spcPts val="1200"/>
+                <a:spcPts val="900"/>
               </a:spcAft>
               <a:buSzPct val="100000"/>
               <a:buChar char="•"/>
             </a:pPr>
             <a:r>
-              <a:rPr lang="en-US" sz="1500" dirty="0">
+              <a:rPr lang="en-US" sz="1400" dirty="0">
                 <a:solidFill>
                   <a:schemeClr val="tx1"/>
                 </a:solidFill>
               </a:rPr>
+              <a:t>查询改为按“靶点–疾病”，优先遗传学与动物模型证据</a:t>
+            </a:r>
+            <a:endParaRPr lang="en-US" sz="1400" dirty="0"/>
+          </a:p>
+          <a:p>
+            <a:pPr marL="177800" indent="-177800">
+              <a:spcAft>
+                <a:spcPts val="900"/>
+              </a:spcAft>
+              <a:buSzPct val="100000"/>
+              <a:buChar char="•"/>
+            </a:pPr>
+            <a:r>
+              <a:rPr lang="en-US" sz="1400" dirty="0">
+                <a:solidFill>
+                  <a:schemeClr val="tx1"/>
+                </a:solidFill>
+              </a:rPr>
               <a:t>结果稳定后发布正式版，并整理成论文</a:t>
             </a:r>
-            <a:endParaRPr lang="en-US" sz="1500" dirty="0"/>
-          </a:p>
-        </p:txBody>
-      </p:sp>
-      <p:sp>
-        <p:nvSpPr>
-          <p:cNvPr id="16" name="ask-266"/>
+            <a:endParaRPr lang="en-US" sz="1400" dirty="0"/>
+          </a:p>
+        </p:txBody>
+      </p:sp>
+      <p:sp>
+        <p:nvSpPr>
+          <p:cNvPr id="16" name="ask-273"/>
           <p:cNvSpPr/>
           <p:nvPr/>
         </p:nvSpPr>
@@ -3875,7 +3893,7 @@
       </p:sp>
       <p:sp>
         <p:nvSpPr>
-          <p:cNvPr id="17" name="label-267"/>
+          <p:cNvPr id="17" name="label-274"/>
           <p:cNvSpPr txBox="1"/>
           <p:nvPr/>
         </p:nvSpPr>
@@ -14012,7 +14030,7 @@
                   <a:schemeClr val="accent6"/>
                 </a:solidFill>
               </a:rPr>
-              <a:t>A 类设计点 ② 与 ③：用信息论量化分歧、挑选查询；用统计校准决定能否下结论。</a:t>
+              <a:t>A 类设计点 ② 与 ③：用实测数据决定先查什么；用统计校准决定能否下结论。</a:t>
             </a:r>
             <a:endParaRPr lang="en-US" sz="1500" dirty="0"/>
           </a:p>
@@ -14096,7 +14114,7 @@
         <p:spPr>
           <a:xfrm>
             <a:off x="1325880" y="1709928"/>
-            <a:ext cx="3657600" cy="411480"/>
+            <a:ext cx="5897880" cy="411480"/>
           </a:xfrm>
           <a:prstGeom prst="rect">
             <a:avLst/>
@@ -14112,14 +14130,14 @@
               <a:buNone/>
             </a:pPr>
             <a:r>
-              <a:rPr lang="en-US" sz="1800" b="1" dirty="0">
+              <a:rPr lang="en-US" sz="1700" b="1" dirty="0">
                 <a:solidFill>
                   <a:schemeClr val="tx2"/>
                 </a:solidFill>
               </a:rPr>
-              <a:t>信息增益取证</a:t>
-            </a:r>
-            <a:endParaRPr lang="en-US" sz="1800" dirty="0"/>
+              <a:t>信息增益取证：用实测数据决定先查什么</a:t>
+            </a:r>
+            <a:endParaRPr lang="en-US" sz="1700" dirty="0"/>
           </a:p>
         </p:txBody>
       </p:sp>
@@ -14131,12 +14149,12 @@
         </p:nvSpPr>
         <p:spPr>
           <a:xfrm>
-            <a:off x="822960" y="2212848"/>
-            <a:ext cx="6355080" cy="713232"/>
+            <a:off x="822960" y="2194560"/>
+            <a:ext cx="6355080" cy="384048"/>
           </a:xfrm>
           <a:prstGeom prst="roundRect">
             <a:avLst>
-              <a:gd name="adj" fmla="val 10256"/>
+              <a:gd name="adj" fmla="val 19048"/>
             </a:avLst>
           </a:prstGeom>
           <a:solidFill>
@@ -14161,7 +14179,7 @@
                   <a:schemeClr val="tx1"/>
                 </a:solidFill>
               </a:rPr>
-              <a:t>类比：医生分辨流感和感冒——量体温没用，两种病都发烧；流感抗原检测结果差别大，所以先做它。信息增益就是给“这项查询能把两种可能分开多少”打分。</a:t>
+              <a:t>类比：量体温分不开流感和感冒，抗原检测才分得开。信息增益衡量的就是“能分开多少”。</a:t>
             </a:r>
             <a:endParaRPr lang="en-US" sz="1150" dirty="0"/>
           </a:p>
@@ -14175,7 +14193,7 @@
         </p:nvSpPr>
         <p:spPr>
           <a:xfrm>
-            <a:off x="822960" y="3017520"/>
+            <a:off x="822960" y="2651760"/>
             <a:ext cx="6355080" cy="274320"/>
           </a:xfrm>
           <a:prstGeom prst="rect">
@@ -14197,909 +14215,48 @@
                   <a:schemeClr val="tx2"/>
                 </a:solidFill>
               </a:rPr>
-              <a:t>例：假设“GLP-1 受体激动剂（如司美格鲁肽）可用于减重”，起点五五开</a:t>
+              <a:t>实测：真实靶点，已获批（成立）vs 因疗效不足而失败（不成立）</a:t>
             </a:r>
             <a:endParaRPr lang="en-US" sz="1200" dirty="0"/>
           </a:p>
         </p:txBody>
       </p:sp>
-      <p:graphicFrame>
-        <p:nvGraphicFramePr>
-          <p:cNvPr id="9" name="table-176"/>
-          <p:cNvGraphicFramePr>
-            <a:graphicFrameLocks noGrp="1"/>
-          </p:cNvGraphicFramePr>
-          <p:nvPr>
-            <p:extLst>
-              <p:ext uri="{D42A27DB-BD31-4B8C-83A1-F6EECF244321}">
-                <p14:modId xmlns:p14="http://schemas.microsoft.com/office/powerpoint/2010/main" val="1579011935"/>
-              </p:ext>
-            </p:extLst>
-          </p:nvPr>
-        </p:nvGraphicFramePr>
-        <p:xfrm>
-          <a:off x="822960" y="3337560"/>
-          <a:ext cx="3977640" cy="914400"/>
-        </p:xfrm>
-        <a:graphic>
-          <a:graphicData uri="http://schemas.openxmlformats.org/drawingml/2006/table">
-            <a:tbl>
-              <a:tblPr/>
-              <a:tblGrid>
-                <a:gridCol w="1965960"/>
-                <a:gridCol w="1005840"/>
-                <a:gridCol w="1005840"/>
-              </a:tblGrid>
-              <a:tr h="420624">
-                <a:tc>
-                  <a:txBody>
-                    <a:bodyPr/>
-                    <a:lstStyle/>
-                    <a:p>
-                      <a:pPr algn="ctr" indent="0" marL="0">
-                        <a:buNone/>
-                      </a:pPr>
-                      <a:r>
-                        <a:rPr lang="en-US" sz="1100" b="1" dirty="0">
-                          <a:solidFill>
-                            <a:srgbClr val="FFFFFF"/>
-                          </a:solidFill>
-                          <a:latin typeface="Microsoft YaHei" pitchFamily="34" charset="0"/>
-                          <a:ea typeface="Microsoft YaHei" pitchFamily="34" charset="-122"/>
-                          <a:cs typeface="Microsoft YaHei" pitchFamily="34" charset="-120"/>
-                        </a:rPr>
-                        <a:t>系统可做的查询</a:t>
-                      </a:r>
-                      <a:endParaRPr lang="en-US" sz="1100" dirty="0">
-                        <a:latin typeface="Microsoft YaHei" charset="0"/>
-                        <a:ea typeface="Microsoft YaHei" charset="0"/>
-                        <a:cs typeface="Microsoft YaHei" charset="0"/>
-                      </a:endParaRPr>
-                    </a:p>
-                  </a:txBody>
-                  <a:tcPr marL="64008" marR="64008" marT="27432" marB="27432" anchor="ctr">
-                    <a:lnL w="9525" cap="flat" cmpd="sng" algn="ctr">
-                      <a:solidFill>
-                        <a:srgbClr val="D5DCE4"/>
-                      </a:solidFill>
-                      <a:prstDash val="solid"/>
-                      <a:round/>
-                      <a:headEnd type="none" w="med" len="med"/>
-                      <a:tailEnd type="none" w="med" len="med"/>
-                    </a:lnL>
-                    <a:lnR w="9525" cap="flat" cmpd="sng" algn="ctr">
-                      <a:solidFill>
-                        <a:srgbClr val="D5DCE4"/>
-                      </a:solidFill>
-                      <a:prstDash val="solid"/>
-                      <a:round/>
-                      <a:headEnd type="none" w="med" len="med"/>
-                      <a:tailEnd type="none" w="med" len="med"/>
-                    </a:lnR>
-                    <a:lnT w="9525" cap="flat" cmpd="sng" algn="ctr">
-                      <a:solidFill>
-                        <a:srgbClr val="D5DCE4"/>
-                      </a:solidFill>
-                      <a:prstDash val="solid"/>
-                      <a:round/>
-                      <a:headEnd type="none" w="med" len="med"/>
-                      <a:tailEnd type="none" w="med" len="med"/>
-                    </a:lnT>
-                    <a:lnB w="9525" cap="flat" cmpd="sng" algn="ctr">
-                      <a:solidFill>
-                        <a:srgbClr val="D5DCE4"/>
-                      </a:solidFill>
-                      <a:prstDash val="solid"/>
-                      <a:round/>
-                      <a:headEnd type="none" w="med" len="med"/>
-                      <a:tailEnd type="none" w="med" len="med"/>
-                    </a:lnB>
-                    <a:solidFill>
-                      <a:srgbClr val="0F2A44"/>
-                    </a:solidFill>
-                  </a:tcPr>
-                </a:tc>
-                <a:tc>
-                  <a:txBody>
-                    <a:bodyPr/>
-                    <a:lstStyle/>
-                    <a:p>
-                      <a:pPr algn="ctr" indent="0" marL="0">
-                        <a:buNone/>
-                      </a:pPr>
-                      <a:r>
-                        <a:rPr lang="en-US" sz="1100" b="1" dirty="0">
-                          <a:solidFill>
-                            <a:srgbClr val="FFFFFF"/>
-                          </a:solidFill>
-                          <a:latin typeface="Microsoft YaHei" pitchFamily="34" charset="0"/>
-                          <a:ea typeface="Microsoft YaHei" pitchFamily="34" charset="-122"/>
-                          <a:cs typeface="Microsoft YaHei" pitchFamily="34" charset="-120"/>
-                        </a:rPr>
-                        <a:t>假设成立时</a:t>
-                      </a:r>
-                      <a:endParaRPr lang="en-US" sz="1100" dirty="0">
-                        <a:latin typeface="Microsoft YaHei" charset="0"/>
-                        <a:ea typeface="Microsoft YaHei" charset="0"/>
-                        <a:cs typeface="Microsoft YaHei" charset="0"/>
-                      </a:endParaRPr>
-                    </a:p>
-                    <a:p>
-                      <a:pPr algn="ctr" indent="0" marL="0">
-                        <a:buNone/>
-                      </a:pPr>
-                      <a:r>
-                        <a:rPr lang="en-US" sz="1100" b="1" dirty="0">
-                          <a:solidFill>
-                            <a:srgbClr val="FFFFFF"/>
-                          </a:solidFill>
-                          <a:latin typeface="Microsoft YaHei" pitchFamily="34" charset="0"/>
-                          <a:ea typeface="Microsoft YaHei" pitchFamily="34" charset="-122"/>
-                          <a:cs typeface="Microsoft YaHei" pitchFamily="34" charset="-120"/>
-                        </a:rPr>
-                        <a:t>查到的概率</a:t>
-                      </a:r>
-                      <a:endParaRPr lang="en-US" sz="1100" dirty="0">
-                        <a:latin typeface="Microsoft YaHei" charset="0"/>
-                        <a:ea typeface="Microsoft YaHei" charset="0"/>
-                        <a:cs typeface="Microsoft YaHei" charset="0"/>
-                      </a:endParaRPr>
-                    </a:p>
-                  </a:txBody>
-                  <a:tcPr marL="64008" marR="64008" marT="27432" marB="27432" anchor="ctr">
-                    <a:lnL w="9525" cap="flat" cmpd="sng" algn="ctr">
-                      <a:solidFill>
-                        <a:srgbClr val="D5DCE4"/>
-                      </a:solidFill>
-                      <a:prstDash val="solid"/>
-                      <a:round/>
-                      <a:headEnd type="none" w="med" len="med"/>
-                      <a:tailEnd type="none" w="med" len="med"/>
-                    </a:lnL>
-                    <a:lnR w="9525" cap="flat" cmpd="sng" algn="ctr">
-                      <a:solidFill>
-                        <a:srgbClr val="D5DCE4"/>
-                      </a:solidFill>
-                      <a:prstDash val="solid"/>
-                      <a:round/>
-                      <a:headEnd type="none" w="med" len="med"/>
-                      <a:tailEnd type="none" w="med" len="med"/>
-                    </a:lnR>
-                    <a:lnT w="9525" cap="flat" cmpd="sng" algn="ctr">
-                      <a:solidFill>
-                        <a:srgbClr val="D5DCE4"/>
-                      </a:solidFill>
-                      <a:prstDash val="solid"/>
-                      <a:round/>
-                      <a:headEnd type="none" w="med" len="med"/>
-                      <a:tailEnd type="none" w="med" len="med"/>
-                    </a:lnT>
-                    <a:lnB w="9525" cap="flat" cmpd="sng" algn="ctr">
-                      <a:solidFill>
-                        <a:srgbClr val="D5DCE4"/>
-                      </a:solidFill>
-                      <a:prstDash val="solid"/>
-                      <a:round/>
-                      <a:headEnd type="none" w="med" len="med"/>
-                      <a:tailEnd type="none" w="med" len="med"/>
-                    </a:lnB>
-                    <a:solidFill>
-                      <a:srgbClr val="0F2A44"/>
-                    </a:solidFill>
-                  </a:tcPr>
-                </a:tc>
-                <a:tc>
-                  <a:txBody>
-                    <a:bodyPr/>
-                    <a:lstStyle/>
-                    <a:p>
-                      <a:pPr algn="ctr" indent="0" marL="0">
-                        <a:buNone/>
-                      </a:pPr>
-                      <a:r>
-                        <a:rPr lang="en-US" sz="1100" b="1" dirty="0">
-                          <a:solidFill>
-                            <a:srgbClr val="FFFFFF"/>
-                          </a:solidFill>
-                          <a:latin typeface="Microsoft YaHei" pitchFamily="34" charset="0"/>
-                          <a:ea typeface="Microsoft YaHei" pitchFamily="34" charset="-122"/>
-                          <a:cs typeface="Microsoft YaHei" pitchFamily="34" charset="-120"/>
-                        </a:rPr>
-                        <a:t>不成立时</a:t>
-                      </a:r>
-                      <a:endParaRPr lang="en-US" sz="1100" dirty="0">
-                        <a:latin typeface="Microsoft YaHei" charset="0"/>
-                        <a:ea typeface="Microsoft YaHei" charset="0"/>
-                        <a:cs typeface="Microsoft YaHei" charset="0"/>
-                      </a:endParaRPr>
-                    </a:p>
-                    <a:p>
-                      <a:pPr algn="ctr" indent="0" marL="0">
-                        <a:buNone/>
-                      </a:pPr>
-                      <a:r>
-                        <a:rPr lang="en-US" sz="1100" b="1" dirty="0">
-                          <a:solidFill>
-                            <a:srgbClr val="FFFFFF"/>
-                          </a:solidFill>
-                          <a:latin typeface="Microsoft YaHei" pitchFamily="34" charset="0"/>
-                          <a:ea typeface="Microsoft YaHei" pitchFamily="34" charset="-122"/>
-                          <a:cs typeface="Microsoft YaHei" pitchFamily="34" charset="-120"/>
-                        </a:rPr>
-                        <a:t>查到的概率</a:t>
-                      </a:r>
-                      <a:endParaRPr lang="en-US" sz="1100" dirty="0">
-                        <a:latin typeface="Microsoft YaHei" charset="0"/>
-                        <a:ea typeface="Microsoft YaHei" charset="0"/>
-                        <a:cs typeface="Microsoft YaHei" charset="0"/>
-                      </a:endParaRPr>
-                    </a:p>
-                  </a:txBody>
-                  <a:tcPr marL="64008" marR="64008" marT="27432" marB="27432" anchor="ctr">
-                    <a:lnL w="9525" cap="flat" cmpd="sng" algn="ctr">
-                      <a:solidFill>
-                        <a:srgbClr val="D5DCE4"/>
-                      </a:solidFill>
-                      <a:prstDash val="solid"/>
-                      <a:round/>
-                      <a:headEnd type="none" w="med" len="med"/>
-                      <a:tailEnd type="none" w="med" len="med"/>
-                    </a:lnL>
-                    <a:lnR w="9525" cap="flat" cmpd="sng" algn="ctr">
-                      <a:solidFill>
-                        <a:srgbClr val="D5DCE4"/>
-                      </a:solidFill>
-                      <a:prstDash val="solid"/>
-                      <a:round/>
-                      <a:headEnd type="none" w="med" len="med"/>
-                      <a:tailEnd type="none" w="med" len="med"/>
-                    </a:lnR>
-                    <a:lnT w="9525" cap="flat" cmpd="sng" algn="ctr">
-                      <a:solidFill>
-                        <a:srgbClr val="D5DCE4"/>
-                      </a:solidFill>
-                      <a:prstDash val="solid"/>
-                      <a:round/>
-                      <a:headEnd type="none" w="med" len="med"/>
-                      <a:tailEnd type="none" w="med" len="med"/>
-                    </a:lnT>
-                    <a:lnB w="9525" cap="flat" cmpd="sng" algn="ctr">
-                      <a:solidFill>
-                        <a:srgbClr val="D5DCE4"/>
-                      </a:solidFill>
-                      <a:prstDash val="solid"/>
-                      <a:round/>
-                      <a:headEnd type="none" w="med" len="med"/>
-                      <a:tailEnd type="none" w="med" len="med"/>
-                    </a:lnB>
-                    <a:solidFill>
-                      <a:srgbClr val="0F2A44"/>
-                    </a:solidFill>
-                  </a:tcPr>
-                </a:tc>
-              </a:tr>
-              <a:tr h="347472">
-                <a:tc>
-                  <a:txBody>
-                    <a:bodyPr/>
-                    <a:lstStyle/>
-                    <a:p>
-                      <a:pPr algn="l" indent="0" marL="0">
-                        <a:buNone/>
-                      </a:pPr>
-                      <a:r>
-                        <a:rPr lang="en-US" sz="1100" dirty="0">
-                          <a:solidFill>
-                            <a:srgbClr val="1B2533"/>
-                          </a:solidFill>
-                          <a:latin typeface="Microsoft YaHei" pitchFamily="34" charset="0"/>
-                          <a:ea typeface="Microsoft YaHei" pitchFamily="34" charset="-122"/>
-                          <a:cs typeface="Microsoft YaHei" pitchFamily="34" charset="-120"/>
-                        </a:rPr>
-                        <a:t>查强活性药物（ChEMBL）</a:t>
-                      </a:r>
-                      <a:endParaRPr lang="en-US" sz="1100" dirty="0">
-                        <a:latin typeface="Microsoft YaHei" charset="0"/>
-                        <a:ea typeface="Microsoft YaHei" charset="0"/>
-                        <a:cs typeface="Microsoft YaHei" charset="0"/>
-                      </a:endParaRPr>
-                    </a:p>
-                  </a:txBody>
-                  <a:tcPr marL="64008" marR="64008" marT="27432" marB="27432" anchor="ctr">
-                    <a:lnL w="9525" cap="flat" cmpd="sng" algn="ctr">
-                      <a:solidFill>
-                        <a:srgbClr val="D5DCE4"/>
-                      </a:solidFill>
-                      <a:prstDash val="solid"/>
-                      <a:round/>
-                      <a:headEnd type="none" w="med" len="med"/>
-                      <a:tailEnd type="none" w="med" len="med"/>
-                    </a:lnL>
-                    <a:lnR w="9525" cap="flat" cmpd="sng" algn="ctr">
-                      <a:solidFill>
-                        <a:srgbClr val="D5DCE4"/>
-                      </a:solidFill>
-                      <a:prstDash val="solid"/>
-                      <a:round/>
-                      <a:headEnd type="none" w="med" len="med"/>
-                      <a:tailEnd type="none" w="med" len="med"/>
-                    </a:lnR>
-                    <a:lnT w="9525" cap="flat" cmpd="sng" algn="ctr">
-                      <a:solidFill>
-                        <a:srgbClr val="D5DCE4"/>
-                      </a:solidFill>
-                      <a:prstDash val="solid"/>
-                      <a:round/>
-                      <a:headEnd type="none" w="med" len="med"/>
-                      <a:tailEnd type="none" w="med" len="med"/>
-                    </a:lnT>
-                    <a:lnB w="9525" cap="flat" cmpd="sng" algn="ctr">
-                      <a:solidFill>
-                        <a:srgbClr val="D5DCE4"/>
-                      </a:solidFill>
-                      <a:prstDash val="solid"/>
-                      <a:round/>
-                      <a:headEnd type="none" w="med" len="med"/>
-                      <a:tailEnd type="none" w="med" len="med"/>
-                    </a:lnB>
-                    <a:solidFill>
-                      <a:srgbClr val="FFFFFF"/>
-                    </a:solidFill>
-                  </a:tcPr>
-                </a:tc>
-                <a:tc>
-                  <a:txBody>
-                    <a:bodyPr/>
-                    <a:lstStyle/>
-                    <a:p>
-                      <a:pPr algn="ctr" indent="0" marL="0">
-                        <a:buNone/>
-                      </a:pPr>
-                      <a:r>
-                        <a:rPr lang="en-US" sz="1100" b="1" dirty="0">
-                          <a:solidFill>
-                            <a:srgbClr val="1B2533"/>
-                          </a:solidFill>
-                          <a:latin typeface="Microsoft YaHei" pitchFamily="34" charset="0"/>
-                          <a:ea typeface="Microsoft YaHei" pitchFamily="34" charset="-122"/>
-                          <a:cs typeface="Microsoft YaHei" pitchFamily="34" charset="-120"/>
-                        </a:rPr>
-                        <a:t>60%</a:t>
-                      </a:r>
-                      <a:endParaRPr lang="en-US" sz="1100" dirty="0">
-                        <a:latin typeface="Microsoft YaHei" charset="0"/>
-                        <a:ea typeface="Microsoft YaHei" charset="0"/>
-                        <a:cs typeface="Microsoft YaHei" charset="0"/>
-                      </a:endParaRPr>
-                    </a:p>
-                  </a:txBody>
-                  <a:tcPr marL="64008" marR="64008" marT="27432" marB="27432" anchor="ctr">
-                    <a:lnL w="9525" cap="flat" cmpd="sng" algn="ctr">
-                      <a:solidFill>
-                        <a:srgbClr val="D5DCE4"/>
-                      </a:solidFill>
-                      <a:prstDash val="solid"/>
-                      <a:round/>
-                      <a:headEnd type="none" w="med" len="med"/>
-                      <a:tailEnd type="none" w="med" len="med"/>
-                    </a:lnL>
-                    <a:lnR w="9525" cap="flat" cmpd="sng" algn="ctr">
-                      <a:solidFill>
-                        <a:srgbClr val="D5DCE4"/>
-                      </a:solidFill>
-                      <a:prstDash val="solid"/>
-                      <a:round/>
-                      <a:headEnd type="none" w="med" len="med"/>
-                      <a:tailEnd type="none" w="med" len="med"/>
-                    </a:lnR>
-                    <a:lnT w="9525" cap="flat" cmpd="sng" algn="ctr">
-                      <a:solidFill>
-                        <a:srgbClr val="D5DCE4"/>
-                      </a:solidFill>
-                      <a:prstDash val="solid"/>
-                      <a:round/>
-                      <a:headEnd type="none" w="med" len="med"/>
-                      <a:tailEnd type="none" w="med" len="med"/>
-                    </a:lnT>
-                    <a:lnB w="9525" cap="flat" cmpd="sng" algn="ctr">
-                      <a:solidFill>
-                        <a:srgbClr val="D5DCE4"/>
-                      </a:solidFill>
-                      <a:prstDash val="solid"/>
-                      <a:round/>
-                      <a:headEnd type="none" w="med" len="med"/>
-                      <a:tailEnd type="none" w="med" len="med"/>
-                    </a:lnB>
-                    <a:solidFill>
-                      <a:srgbClr val="FFFFFF"/>
-                    </a:solidFill>
-                  </a:tcPr>
-                </a:tc>
-                <a:tc>
-                  <a:txBody>
-                    <a:bodyPr/>
-                    <a:lstStyle/>
-                    <a:p>
-                      <a:pPr algn="ctr" indent="0" marL="0">
-                        <a:buNone/>
-                      </a:pPr>
-                      <a:r>
-                        <a:rPr lang="en-US" sz="1100" b="1" dirty="0">
-                          <a:solidFill>
-                            <a:srgbClr val="1B2533"/>
-                          </a:solidFill>
-                          <a:latin typeface="Microsoft YaHei" pitchFamily="34" charset="0"/>
-                          <a:ea typeface="Microsoft YaHei" pitchFamily="34" charset="-122"/>
-                          <a:cs typeface="Microsoft YaHei" pitchFamily="34" charset="-120"/>
-                        </a:rPr>
-                        <a:t>10%</a:t>
-                      </a:r>
-                      <a:endParaRPr lang="en-US" sz="1100" dirty="0">
-                        <a:latin typeface="Microsoft YaHei" charset="0"/>
-                        <a:ea typeface="Microsoft YaHei" charset="0"/>
-                        <a:cs typeface="Microsoft YaHei" charset="0"/>
-                      </a:endParaRPr>
-                    </a:p>
-                  </a:txBody>
-                  <a:tcPr marL="64008" marR="64008" marT="27432" marB="27432" anchor="ctr">
-                    <a:lnL w="9525" cap="flat" cmpd="sng" algn="ctr">
-                      <a:solidFill>
-                        <a:srgbClr val="D5DCE4"/>
-                      </a:solidFill>
-                      <a:prstDash val="solid"/>
-                      <a:round/>
-                      <a:headEnd type="none" w="med" len="med"/>
-                      <a:tailEnd type="none" w="med" len="med"/>
-                    </a:lnL>
-                    <a:lnR w="9525" cap="flat" cmpd="sng" algn="ctr">
-                      <a:solidFill>
-                        <a:srgbClr val="D5DCE4"/>
-                      </a:solidFill>
-                      <a:prstDash val="solid"/>
-                      <a:round/>
-                      <a:headEnd type="none" w="med" len="med"/>
-                      <a:tailEnd type="none" w="med" len="med"/>
-                    </a:lnR>
-                    <a:lnT w="9525" cap="flat" cmpd="sng" algn="ctr">
-                      <a:solidFill>
-                        <a:srgbClr val="D5DCE4"/>
-                      </a:solidFill>
-                      <a:prstDash val="solid"/>
-                      <a:round/>
-                      <a:headEnd type="none" w="med" len="med"/>
-                      <a:tailEnd type="none" w="med" len="med"/>
-                    </a:lnT>
-                    <a:lnB w="9525" cap="flat" cmpd="sng" algn="ctr">
-                      <a:solidFill>
-                        <a:srgbClr val="D5DCE4"/>
-                      </a:solidFill>
-                      <a:prstDash val="solid"/>
-                      <a:round/>
-                      <a:headEnd type="none" w="med" len="med"/>
-                      <a:tailEnd type="none" w="med" len="med"/>
-                    </a:lnB>
-                    <a:solidFill>
-                      <a:srgbClr val="FFFFFF"/>
-                    </a:solidFill>
-                  </a:tcPr>
-                </a:tc>
-              </a:tr>
-              <a:tr h="347472">
-                <a:tc>
-                  <a:txBody>
-                    <a:bodyPr/>
-                    <a:lstStyle/>
-                    <a:p>
-                      <a:pPr algn="l" indent="0" marL="0">
-                        <a:buNone/>
-                      </a:pPr>
-                      <a:r>
-                        <a:rPr lang="en-US" sz="1100" dirty="0">
-                          <a:solidFill>
-                            <a:srgbClr val="1B2533"/>
-                          </a:solidFill>
-                          <a:latin typeface="Microsoft YaHei" pitchFamily="34" charset="0"/>
-                          <a:ea typeface="Microsoft YaHei" pitchFamily="34" charset="-122"/>
-                          <a:cs typeface="Microsoft YaHei" pitchFamily="34" charset="-120"/>
-                        </a:rPr>
-                        <a:t>查临床试验登记</a:t>
-                      </a:r>
-                      <a:endParaRPr lang="en-US" sz="1100" dirty="0">
-                        <a:latin typeface="Microsoft YaHei" charset="0"/>
-                        <a:ea typeface="Microsoft YaHei" charset="0"/>
-                        <a:cs typeface="Microsoft YaHei" charset="0"/>
-                      </a:endParaRPr>
-                    </a:p>
-                  </a:txBody>
-                  <a:tcPr marL="64008" marR="64008" marT="27432" marB="27432" anchor="ctr">
-                    <a:lnL w="9525" cap="flat" cmpd="sng" algn="ctr">
-                      <a:solidFill>
-                        <a:srgbClr val="D5DCE4"/>
-                      </a:solidFill>
-                      <a:prstDash val="solid"/>
-                      <a:round/>
-                      <a:headEnd type="none" w="med" len="med"/>
-                      <a:tailEnd type="none" w="med" len="med"/>
-                    </a:lnL>
-                    <a:lnR w="9525" cap="flat" cmpd="sng" algn="ctr">
-                      <a:solidFill>
-                        <a:srgbClr val="D5DCE4"/>
-                      </a:solidFill>
-                      <a:prstDash val="solid"/>
-                      <a:round/>
-                      <a:headEnd type="none" w="med" len="med"/>
-                      <a:tailEnd type="none" w="med" len="med"/>
-                    </a:lnR>
-                    <a:lnT w="9525" cap="flat" cmpd="sng" algn="ctr">
-                      <a:solidFill>
-                        <a:srgbClr val="D5DCE4"/>
-                      </a:solidFill>
-                      <a:prstDash val="solid"/>
-                      <a:round/>
-                      <a:headEnd type="none" w="med" len="med"/>
-                      <a:tailEnd type="none" w="med" len="med"/>
-                    </a:lnT>
-                    <a:lnB w="9525" cap="flat" cmpd="sng" algn="ctr">
-                      <a:solidFill>
-                        <a:srgbClr val="D5DCE4"/>
-                      </a:solidFill>
-                      <a:prstDash val="solid"/>
-                      <a:round/>
-                      <a:headEnd type="none" w="med" len="med"/>
-                      <a:tailEnd type="none" w="med" len="med"/>
-                    </a:lnB>
-                    <a:solidFill>
-                      <a:srgbClr val="FFFFFF"/>
-                    </a:solidFill>
-                  </a:tcPr>
-                </a:tc>
-                <a:tc>
-                  <a:txBody>
-                    <a:bodyPr/>
-                    <a:lstStyle/>
-                    <a:p>
-                      <a:pPr algn="ctr" indent="0" marL="0">
-                        <a:buNone/>
-                      </a:pPr>
-                      <a:r>
-                        <a:rPr lang="en-US" sz="1100" b="1" dirty="0">
-                          <a:solidFill>
-                            <a:srgbClr val="1B2533"/>
-                          </a:solidFill>
-                          <a:latin typeface="Microsoft YaHei" pitchFamily="34" charset="0"/>
-                          <a:ea typeface="Microsoft YaHei" pitchFamily="34" charset="-122"/>
-                          <a:cs typeface="Microsoft YaHei" pitchFamily="34" charset="-120"/>
-                        </a:rPr>
-                        <a:t>50%</a:t>
-                      </a:r>
-                      <a:endParaRPr lang="en-US" sz="1100" dirty="0">
-                        <a:latin typeface="Microsoft YaHei" charset="0"/>
-                        <a:ea typeface="Microsoft YaHei" charset="0"/>
-                        <a:cs typeface="Microsoft YaHei" charset="0"/>
-                      </a:endParaRPr>
-                    </a:p>
-                  </a:txBody>
-                  <a:tcPr marL="64008" marR="64008" marT="27432" marB="27432" anchor="ctr">
-                    <a:lnL w="9525" cap="flat" cmpd="sng" algn="ctr">
-                      <a:solidFill>
-                        <a:srgbClr val="D5DCE4"/>
-                      </a:solidFill>
-                      <a:prstDash val="solid"/>
-                      <a:round/>
-                      <a:headEnd type="none" w="med" len="med"/>
-                      <a:tailEnd type="none" w="med" len="med"/>
-                    </a:lnL>
-                    <a:lnR w="9525" cap="flat" cmpd="sng" algn="ctr">
-                      <a:solidFill>
-                        <a:srgbClr val="D5DCE4"/>
-                      </a:solidFill>
-                      <a:prstDash val="solid"/>
-                      <a:round/>
-                      <a:headEnd type="none" w="med" len="med"/>
-                      <a:tailEnd type="none" w="med" len="med"/>
-                    </a:lnR>
-                    <a:lnT w="9525" cap="flat" cmpd="sng" algn="ctr">
-                      <a:solidFill>
-                        <a:srgbClr val="D5DCE4"/>
-                      </a:solidFill>
-                      <a:prstDash val="solid"/>
-                      <a:round/>
-                      <a:headEnd type="none" w="med" len="med"/>
-                      <a:tailEnd type="none" w="med" len="med"/>
-                    </a:lnT>
-                    <a:lnB w="9525" cap="flat" cmpd="sng" algn="ctr">
-                      <a:solidFill>
-                        <a:srgbClr val="D5DCE4"/>
-                      </a:solidFill>
-                      <a:prstDash val="solid"/>
-                      <a:round/>
-                      <a:headEnd type="none" w="med" len="med"/>
-                      <a:tailEnd type="none" w="med" len="med"/>
-                    </a:lnB>
-                    <a:solidFill>
-                      <a:srgbClr val="FFFFFF"/>
-                    </a:solidFill>
-                  </a:tcPr>
-                </a:tc>
-                <a:tc>
-                  <a:txBody>
-                    <a:bodyPr/>
-                    <a:lstStyle/>
-                    <a:p>
-                      <a:pPr algn="ctr" indent="0" marL="0">
-                        <a:buNone/>
-                      </a:pPr>
-                      <a:r>
-                        <a:rPr lang="en-US" sz="1100" b="1" dirty="0">
-                          <a:solidFill>
-                            <a:srgbClr val="1B2533"/>
-                          </a:solidFill>
-                          <a:latin typeface="Microsoft YaHei" pitchFamily="34" charset="0"/>
-                          <a:ea typeface="Microsoft YaHei" pitchFamily="34" charset="-122"/>
-                          <a:cs typeface="Microsoft YaHei" pitchFamily="34" charset="-120"/>
-                        </a:rPr>
-                        <a:t>15%</a:t>
-                      </a:r>
-                      <a:endParaRPr lang="en-US" sz="1100" dirty="0">
-                        <a:latin typeface="Microsoft YaHei" charset="0"/>
-                        <a:ea typeface="Microsoft YaHei" charset="0"/>
-                        <a:cs typeface="Microsoft YaHei" charset="0"/>
-                      </a:endParaRPr>
-                    </a:p>
-                  </a:txBody>
-                  <a:tcPr marL="64008" marR="64008" marT="27432" marB="27432" anchor="ctr">
-                    <a:lnL w="9525" cap="flat" cmpd="sng" algn="ctr">
-                      <a:solidFill>
-                        <a:srgbClr val="D5DCE4"/>
-                      </a:solidFill>
-                      <a:prstDash val="solid"/>
-                      <a:round/>
-                      <a:headEnd type="none" w="med" len="med"/>
-                      <a:tailEnd type="none" w="med" len="med"/>
-                    </a:lnL>
-                    <a:lnR w="9525" cap="flat" cmpd="sng" algn="ctr">
-                      <a:solidFill>
-                        <a:srgbClr val="D5DCE4"/>
-                      </a:solidFill>
-                      <a:prstDash val="solid"/>
-                      <a:round/>
-                      <a:headEnd type="none" w="med" len="med"/>
-                      <a:tailEnd type="none" w="med" len="med"/>
-                    </a:lnR>
-                    <a:lnT w="9525" cap="flat" cmpd="sng" algn="ctr">
-                      <a:solidFill>
-                        <a:srgbClr val="D5DCE4"/>
-                      </a:solidFill>
-                      <a:prstDash val="solid"/>
-                      <a:round/>
-                      <a:headEnd type="none" w="med" len="med"/>
-                      <a:tailEnd type="none" w="med" len="med"/>
-                    </a:lnT>
-                    <a:lnB w="9525" cap="flat" cmpd="sng" algn="ctr">
-                      <a:solidFill>
-                        <a:srgbClr val="D5DCE4"/>
-                      </a:solidFill>
-                      <a:prstDash val="solid"/>
-                      <a:round/>
-                      <a:headEnd type="none" w="med" len="med"/>
-                      <a:tailEnd type="none" w="med" len="med"/>
-                    </a:lnB>
-                    <a:solidFill>
-                      <a:srgbClr val="FFFFFF"/>
-                    </a:solidFill>
-                  </a:tcPr>
-                </a:tc>
-              </a:tr>
-              <a:tr h="347472">
-                <a:tc>
-                  <a:txBody>
-                    <a:bodyPr/>
-                    <a:lstStyle/>
-                    <a:p>
-                      <a:pPr algn="l" indent="0" marL="0">
-                        <a:buNone/>
-                      </a:pPr>
-                      <a:r>
-                        <a:rPr lang="en-US" sz="1100" dirty="0">
-                          <a:solidFill>
-                            <a:srgbClr val="1B2533"/>
-                          </a:solidFill>
-                          <a:latin typeface="Microsoft YaHei" pitchFamily="34" charset="0"/>
-                          <a:ea typeface="Microsoft YaHei" pitchFamily="34" charset="-122"/>
-                          <a:cs typeface="Microsoft YaHei" pitchFamily="34" charset="-120"/>
-                        </a:rPr>
-                        <a:t>查靶点序列（UniProt）</a:t>
-                      </a:r>
-                      <a:endParaRPr lang="en-US" sz="1100" dirty="0">
-                        <a:latin typeface="Microsoft YaHei" charset="0"/>
-                        <a:ea typeface="Microsoft YaHei" charset="0"/>
-                        <a:cs typeface="Microsoft YaHei" charset="0"/>
-                      </a:endParaRPr>
-                    </a:p>
-                  </a:txBody>
-                  <a:tcPr marL="64008" marR="64008" marT="27432" marB="27432" anchor="ctr">
-                    <a:lnL w="9525" cap="flat" cmpd="sng" algn="ctr">
-                      <a:solidFill>
-                        <a:srgbClr val="D5DCE4"/>
-                      </a:solidFill>
-                      <a:prstDash val="solid"/>
-                      <a:round/>
-                      <a:headEnd type="none" w="med" len="med"/>
-                      <a:tailEnd type="none" w="med" len="med"/>
-                    </a:lnL>
-                    <a:lnR w="9525" cap="flat" cmpd="sng" algn="ctr">
-                      <a:solidFill>
-                        <a:srgbClr val="D5DCE4"/>
-                      </a:solidFill>
-                      <a:prstDash val="solid"/>
-                      <a:round/>
-                      <a:headEnd type="none" w="med" len="med"/>
-                      <a:tailEnd type="none" w="med" len="med"/>
-                    </a:lnR>
-                    <a:lnT w="9525" cap="flat" cmpd="sng" algn="ctr">
-                      <a:solidFill>
-                        <a:srgbClr val="D5DCE4"/>
-                      </a:solidFill>
-                      <a:prstDash val="solid"/>
-                      <a:round/>
-                      <a:headEnd type="none" w="med" len="med"/>
-                      <a:tailEnd type="none" w="med" len="med"/>
-                    </a:lnT>
-                    <a:lnB w="9525" cap="flat" cmpd="sng" algn="ctr">
-                      <a:solidFill>
-                        <a:srgbClr val="D5DCE4"/>
-                      </a:solidFill>
-                      <a:prstDash val="solid"/>
-                      <a:round/>
-                      <a:headEnd type="none" w="med" len="med"/>
-                      <a:tailEnd type="none" w="med" len="med"/>
-                    </a:lnB>
-                    <a:solidFill>
-                      <a:srgbClr val="FFFFFF"/>
-                    </a:solidFill>
-                  </a:tcPr>
-                </a:tc>
-                <a:tc>
-                  <a:txBody>
-                    <a:bodyPr/>
-                    <a:lstStyle/>
-                    <a:p>
-                      <a:pPr algn="ctr" indent="0" marL="0">
-                        <a:buNone/>
-                      </a:pPr>
-                      <a:r>
-                        <a:rPr lang="en-US" sz="1100" b="1" dirty="0">
-                          <a:solidFill>
-                            <a:srgbClr val="1B2533"/>
-                          </a:solidFill>
-                          <a:latin typeface="Microsoft YaHei" pitchFamily="34" charset="0"/>
-                          <a:ea typeface="Microsoft YaHei" pitchFamily="34" charset="-122"/>
-                          <a:cs typeface="Microsoft YaHei" pitchFamily="34" charset="-120"/>
-                        </a:rPr>
-                        <a:t>95%</a:t>
-                      </a:r>
-                      <a:endParaRPr lang="en-US" sz="1100" dirty="0">
-                        <a:latin typeface="Microsoft YaHei" charset="0"/>
-                        <a:ea typeface="Microsoft YaHei" charset="0"/>
-                        <a:cs typeface="Microsoft YaHei" charset="0"/>
-                      </a:endParaRPr>
-                    </a:p>
-                  </a:txBody>
-                  <a:tcPr marL="64008" marR="64008" marT="27432" marB="27432" anchor="ctr">
-                    <a:lnL w="9525" cap="flat" cmpd="sng" algn="ctr">
-                      <a:solidFill>
-                        <a:srgbClr val="D5DCE4"/>
-                      </a:solidFill>
-                      <a:prstDash val="solid"/>
-                      <a:round/>
-                      <a:headEnd type="none" w="med" len="med"/>
-                      <a:tailEnd type="none" w="med" len="med"/>
-                    </a:lnL>
-                    <a:lnR w="9525" cap="flat" cmpd="sng" algn="ctr">
-                      <a:solidFill>
-                        <a:srgbClr val="D5DCE4"/>
-                      </a:solidFill>
-                      <a:prstDash val="solid"/>
-                      <a:round/>
-                      <a:headEnd type="none" w="med" len="med"/>
-                      <a:tailEnd type="none" w="med" len="med"/>
-                    </a:lnR>
-                    <a:lnT w="9525" cap="flat" cmpd="sng" algn="ctr">
-                      <a:solidFill>
-                        <a:srgbClr val="D5DCE4"/>
-                      </a:solidFill>
-                      <a:prstDash val="solid"/>
-                      <a:round/>
-                      <a:headEnd type="none" w="med" len="med"/>
-                      <a:tailEnd type="none" w="med" len="med"/>
-                    </a:lnT>
-                    <a:lnB w="9525" cap="flat" cmpd="sng" algn="ctr">
-                      <a:solidFill>
-                        <a:srgbClr val="D5DCE4"/>
-                      </a:solidFill>
-                      <a:prstDash val="solid"/>
-                      <a:round/>
-                      <a:headEnd type="none" w="med" len="med"/>
-                      <a:tailEnd type="none" w="med" len="med"/>
-                    </a:lnB>
-                    <a:solidFill>
-                      <a:srgbClr val="FFFFFF"/>
-                    </a:solidFill>
-                  </a:tcPr>
-                </a:tc>
-                <a:tc>
-                  <a:txBody>
-                    <a:bodyPr/>
-                    <a:lstStyle/>
-                    <a:p>
-                      <a:pPr algn="ctr" indent="0" marL="0">
-                        <a:buNone/>
-                      </a:pPr>
-                      <a:r>
-                        <a:rPr lang="en-US" sz="1100" b="1" dirty="0">
-                          <a:solidFill>
-                            <a:srgbClr val="1B2533"/>
-                          </a:solidFill>
-                          <a:latin typeface="Microsoft YaHei" pitchFamily="34" charset="0"/>
-                          <a:ea typeface="Microsoft YaHei" pitchFamily="34" charset="-122"/>
-                          <a:cs typeface="Microsoft YaHei" pitchFamily="34" charset="-120"/>
-                        </a:rPr>
-                        <a:t>80%</a:t>
-                      </a:r>
-                      <a:endParaRPr lang="en-US" sz="1100" dirty="0">
-                        <a:latin typeface="Microsoft YaHei" charset="0"/>
-                        <a:ea typeface="Microsoft YaHei" charset="0"/>
-                        <a:cs typeface="Microsoft YaHei" charset="0"/>
-                      </a:endParaRPr>
-                    </a:p>
-                  </a:txBody>
-                  <a:tcPr marL="64008" marR="64008" marT="27432" marB="27432" anchor="ctr">
-                    <a:lnL w="9525" cap="flat" cmpd="sng" algn="ctr">
-                      <a:solidFill>
-                        <a:srgbClr val="D5DCE4"/>
-                      </a:solidFill>
-                      <a:prstDash val="solid"/>
-                      <a:round/>
-                      <a:headEnd type="none" w="med" len="med"/>
-                      <a:tailEnd type="none" w="med" len="med"/>
-                    </a:lnL>
-                    <a:lnR w="9525" cap="flat" cmpd="sng" algn="ctr">
-                      <a:solidFill>
-                        <a:srgbClr val="D5DCE4"/>
-                      </a:solidFill>
-                      <a:prstDash val="solid"/>
-                      <a:round/>
-                      <a:headEnd type="none" w="med" len="med"/>
-                      <a:tailEnd type="none" w="med" len="med"/>
-                    </a:lnR>
-                    <a:lnT w="9525" cap="flat" cmpd="sng" algn="ctr">
-                      <a:solidFill>
-                        <a:srgbClr val="D5DCE4"/>
-                      </a:solidFill>
-                      <a:prstDash val="solid"/>
-                      <a:round/>
-                      <a:headEnd type="none" w="med" len="med"/>
-                      <a:tailEnd type="none" w="med" len="med"/>
-                    </a:lnT>
-                    <a:lnB w="9525" cap="flat" cmpd="sng" algn="ctr">
-                      <a:solidFill>
-                        <a:srgbClr val="D5DCE4"/>
-                      </a:solidFill>
-                      <a:prstDash val="solid"/>
-                      <a:round/>
-                      <a:headEnd type="none" w="med" len="med"/>
-                      <a:tailEnd type="none" w="med" len="med"/>
-                    </a:lnB>
-                    <a:solidFill>
-                      <a:srgbClr val="FFFFFF"/>
-                    </a:solidFill>
-                  </a:tcPr>
-                </a:tc>
-              </a:tr>
-            </a:tbl>
-          </a:graphicData>
-        </a:graphic>
-      </p:graphicFrame>
+      <p:sp>
+        <p:nvSpPr>
+          <p:cNvPr id="9" name="label-176"/>
+          <p:cNvSpPr txBox="1"/>
+          <p:nvPr/>
+        </p:nvSpPr>
+        <p:spPr>
+          <a:xfrm>
+            <a:off x="2423160" y="2926080"/>
+            <a:ext cx="1325880" cy="237744"/>
+          </a:xfrm>
+          <a:prstGeom prst="rect">
+            <a:avLst/>
+          </a:prstGeom>
+          <a:noFill/>
+          <a:ln/>
+        </p:spPr>
+        <p:txBody>
+          <a:bodyPr wrap="square" lIns="0" tIns="0" rIns="0" bIns="0" rtlCol="0" anchor="t"/>
+          <a:lstStyle/>
+          <a:p>
+            <a:pPr algn="ctr" indent="0" marL="0">
+              <a:buNone/>
+            </a:pPr>
+            <a:r>
+              <a:rPr lang="en-US" sz="950" dirty="0">
+                <a:solidFill>
+                  <a:schemeClr val="accent6"/>
+                </a:solidFill>
+              </a:rPr>
+              <a:t>成立 vs 不成立</a:t>
+            </a:r>
+            <a:endParaRPr lang="en-US" sz="950" dirty="0"/>
+          </a:p>
+        </p:txBody>
+      </p:sp>
       <p:sp>
         <p:nvSpPr>
           <p:cNvPr id="10" name="label-177"/>
@@ -15108,8 +14265,8 @@
         </p:nvSpPr>
         <p:spPr>
           <a:xfrm>
-            <a:off x="4937760" y="3337560"/>
-            <a:ext cx="2240280" cy="420624"/>
+            <a:off x="3749040" y="2926080"/>
+            <a:ext cx="3429000" cy="237744"/>
           </a:xfrm>
           <a:prstGeom prst="rect">
             <a:avLst/>
@@ -15118,6 +14275,78 @@
           <a:ln/>
         </p:spPr>
         <p:txBody>
+          <a:bodyPr wrap="square" lIns="0" tIns="0" rIns="0" bIns="0" rtlCol="0" anchor="t"/>
+          <a:lstStyle/>
+          <a:p>
+            <a:pPr algn="l" indent="0" marL="0">
+              <a:buNone/>
+            </a:pPr>
+            <a:r>
+              <a:rPr lang="en-US" sz="950" dirty="0">
+                <a:solidFill>
+                  <a:schemeClr val="accent6"/>
+                </a:solidFill>
+              </a:rPr>
+              <a:t>信息增益（比特）</a:t>
+            </a:r>
+            <a:endParaRPr lang="en-US" sz="950" dirty="0"/>
+          </a:p>
+        </p:txBody>
+      </p:sp>
+      <p:sp>
+        <p:nvSpPr>
+          <p:cNvPr id="11" name="label-178"/>
+          <p:cNvSpPr txBox="1"/>
+          <p:nvPr/>
+        </p:nvSpPr>
+        <p:spPr>
+          <a:xfrm>
+            <a:off x="822960" y="3163824"/>
+            <a:ext cx="6355080" cy="237744"/>
+          </a:xfrm>
+          <a:prstGeom prst="rect">
+            <a:avLst/>
+          </a:prstGeom>
+          <a:noFill/>
+          <a:ln/>
+        </p:spPr>
+        <p:txBody>
+          <a:bodyPr wrap="square" lIns="0" tIns="0" rIns="0" bIns="0" rtlCol="0" anchor="t"/>
+          <a:lstStyle/>
+          <a:p>
+            <a:pPr algn="l" indent="0" marL="0">
+              <a:buNone/>
+            </a:pPr>
+            <a:r>
+              <a:rPr lang="en-US" sz="1100" b="1" dirty="0">
+                <a:solidFill>
+                  <a:schemeClr val="accent6"/>
+                </a:solidFill>
+              </a:rPr>
+              <a:t>只看靶点本身</a:t>
+            </a:r>
+            <a:endParaRPr lang="en-US" sz="1100" dirty="0"/>
+          </a:p>
+        </p:txBody>
+      </p:sp>
+      <p:sp>
+        <p:nvSpPr>
+          <p:cNvPr id="12" name="label-179"/>
+          <p:cNvSpPr txBox="1"/>
+          <p:nvPr/>
+        </p:nvSpPr>
+        <p:spPr>
+          <a:xfrm>
+            <a:off x="960120" y="3410712"/>
+            <a:ext cx="1463040" cy="246888"/>
+          </a:xfrm>
+          <a:prstGeom prst="rect">
+            <a:avLst/>
+          </a:prstGeom>
+          <a:noFill/>
+          <a:ln/>
+        </p:spPr>
+        <p:txBody>
           <a:bodyPr wrap="square" lIns="0" tIns="0" rIns="0" bIns="0" rtlCol="0" anchor="ctr"/>
           <a:lstStyle/>
           <a:p>
@@ -15125,26 +14354,397 @@
               <a:buNone/>
             </a:pPr>
             <a:r>
+              <a:rPr lang="en-US" sz="1100" dirty="0">
+                <a:solidFill>
+                  <a:schemeClr val="tx1"/>
+                </a:solidFill>
+              </a:rPr>
+              <a:t>查靶点序列</a:t>
+            </a:r>
+            <a:endParaRPr lang="en-US" sz="1100" dirty="0"/>
+          </a:p>
+        </p:txBody>
+      </p:sp>
+      <p:sp>
+        <p:nvSpPr>
+          <p:cNvPr id="13" name="label-180"/>
+          <p:cNvSpPr txBox="1"/>
+          <p:nvPr/>
+        </p:nvSpPr>
+        <p:spPr>
+          <a:xfrm>
+            <a:off x="2423160" y="3410712"/>
+            <a:ext cx="1325880" cy="246888"/>
+          </a:xfrm>
+          <a:prstGeom prst="rect">
+            <a:avLst/>
+          </a:prstGeom>
+          <a:noFill/>
+          <a:ln/>
+        </p:spPr>
+        <p:txBody>
+          <a:bodyPr wrap="square" lIns="0" tIns="0" rIns="0" bIns="0" rtlCol="0" anchor="ctr"/>
+          <a:lstStyle/>
+          <a:p>
+            <a:pPr algn="ctr" indent="0" marL="0">
+              <a:buNone/>
+            </a:pPr>
+            <a:r>
+              <a:rPr lang="en-US" sz="1100" dirty="0">
+                <a:solidFill>
+                  <a:schemeClr val="tx1"/>
+                </a:solidFill>
+              </a:rPr>
+              <a:t>100% vs 100%</a:t>
+            </a:r>
+            <a:endParaRPr lang="en-US" sz="1100" dirty="0"/>
+          </a:p>
+        </p:txBody>
+      </p:sp>
+      <p:sp>
+        <p:nvSpPr>
+          <p:cNvPr id="14" name="label-181"/>
+          <p:cNvSpPr txBox="1"/>
+          <p:nvPr/>
+        </p:nvSpPr>
+        <p:spPr>
+          <a:xfrm>
+            <a:off x="3803904" y="3410712"/>
+            <a:ext cx="548640" cy="246888"/>
+          </a:xfrm>
+          <a:prstGeom prst="rect">
+            <a:avLst/>
+          </a:prstGeom>
+          <a:noFill/>
+          <a:ln/>
+        </p:spPr>
+        <p:txBody>
+          <a:bodyPr wrap="square" lIns="0" tIns="0" rIns="0" bIns="0" rtlCol="0" anchor="ctr"/>
+          <a:lstStyle/>
+          <a:p>
+            <a:pPr algn="l" indent="0" marL="0">
+              <a:buNone/>
+            </a:pPr>
+            <a:r>
+              <a:rPr lang="en-US" sz="1050" b="1" dirty="0">
+                <a:solidFill>
+                  <a:schemeClr val="tx1"/>
+                </a:solidFill>
+              </a:rPr>
+              <a:t>0</a:t>
+            </a:r>
+            <a:endParaRPr lang="en-US" sz="1050" dirty="0"/>
+          </a:p>
+        </p:txBody>
+      </p:sp>
+      <p:sp>
+        <p:nvSpPr>
+          <p:cNvPr id="15" name="label-182"/>
+          <p:cNvSpPr txBox="1"/>
+          <p:nvPr/>
+        </p:nvSpPr>
+        <p:spPr>
+          <a:xfrm>
+            <a:off x="960120" y="3675888"/>
+            <a:ext cx="1463040" cy="246888"/>
+          </a:xfrm>
+          <a:prstGeom prst="rect">
+            <a:avLst/>
+          </a:prstGeom>
+          <a:noFill/>
+          <a:ln/>
+        </p:spPr>
+        <p:txBody>
+          <a:bodyPr wrap="square" lIns="0" tIns="0" rIns="0" bIns="0" rtlCol="0" anchor="ctr"/>
+          <a:lstStyle/>
+          <a:p>
+            <a:pPr algn="l" indent="0" marL="0">
+              <a:buNone/>
+            </a:pPr>
+            <a:r>
+              <a:rPr lang="en-US" sz="1100" dirty="0">
+                <a:solidFill>
+                  <a:schemeClr val="tx1"/>
+                </a:solidFill>
+              </a:rPr>
+              <a:t>查临床试验登记</a:t>
+            </a:r>
+            <a:endParaRPr lang="en-US" sz="1100" dirty="0"/>
+          </a:p>
+        </p:txBody>
+      </p:sp>
+      <p:sp>
+        <p:nvSpPr>
+          <p:cNvPr id="16" name="label-183"/>
+          <p:cNvSpPr txBox="1"/>
+          <p:nvPr/>
+        </p:nvSpPr>
+        <p:spPr>
+          <a:xfrm>
+            <a:off x="2423160" y="3675888"/>
+            <a:ext cx="1325880" cy="246888"/>
+          </a:xfrm>
+          <a:prstGeom prst="rect">
+            <a:avLst/>
+          </a:prstGeom>
+          <a:noFill/>
+          <a:ln/>
+        </p:spPr>
+        <p:txBody>
+          <a:bodyPr wrap="square" lIns="0" tIns="0" rIns="0" bIns="0" rtlCol="0" anchor="ctr"/>
+          <a:lstStyle/>
+          <a:p>
+            <a:pPr algn="ctr" indent="0" marL="0">
+              <a:buNone/>
+            </a:pPr>
+            <a:r>
+              <a:rPr lang="en-US" sz="1100" dirty="0">
+                <a:solidFill>
+                  <a:schemeClr val="tx1"/>
+                </a:solidFill>
+              </a:rPr>
+              <a:t>100% vs 100%</a:t>
+            </a:r>
+            <a:endParaRPr lang="en-US" sz="1100" dirty="0"/>
+          </a:p>
+        </p:txBody>
+      </p:sp>
+      <p:sp>
+        <p:nvSpPr>
+          <p:cNvPr id="17" name="label-184"/>
+          <p:cNvSpPr txBox="1"/>
+          <p:nvPr/>
+        </p:nvSpPr>
+        <p:spPr>
+          <a:xfrm>
+            <a:off x="3803904" y="3675888"/>
+            <a:ext cx="548640" cy="246888"/>
+          </a:xfrm>
+          <a:prstGeom prst="rect">
+            <a:avLst/>
+          </a:prstGeom>
+          <a:noFill/>
+          <a:ln/>
+        </p:spPr>
+        <p:txBody>
+          <a:bodyPr wrap="square" lIns="0" tIns="0" rIns="0" bIns="0" rtlCol="0" anchor="ctr"/>
+          <a:lstStyle/>
+          <a:p>
+            <a:pPr algn="l" indent="0" marL="0">
+              <a:buNone/>
+            </a:pPr>
+            <a:r>
+              <a:rPr lang="en-US" sz="1050" b="1" dirty="0">
+                <a:solidFill>
+                  <a:schemeClr val="tx1"/>
+                </a:solidFill>
+              </a:rPr>
+              <a:t>0</a:t>
+            </a:r>
+            <a:endParaRPr lang="en-US" sz="1050" dirty="0"/>
+          </a:p>
+        </p:txBody>
+      </p:sp>
+      <p:sp>
+        <p:nvSpPr>
+          <p:cNvPr id="18" name="label-185"/>
+          <p:cNvSpPr txBox="1"/>
+          <p:nvPr/>
+        </p:nvSpPr>
+        <p:spPr>
+          <a:xfrm>
+            <a:off x="960120" y="3941064"/>
+            <a:ext cx="1463040" cy="246888"/>
+          </a:xfrm>
+          <a:prstGeom prst="rect">
+            <a:avLst/>
+          </a:prstGeom>
+          <a:noFill/>
+          <a:ln/>
+        </p:spPr>
+        <p:txBody>
+          <a:bodyPr wrap="square" lIns="0" tIns="0" rIns="0" bIns="0" rtlCol="0" anchor="ctr"/>
+          <a:lstStyle/>
+          <a:p>
+            <a:pPr algn="l" indent="0" marL="0">
+              <a:buNone/>
+            </a:pPr>
+            <a:r>
+              <a:rPr lang="en-US" sz="1100" dirty="0">
+                <a:solidFill>
+                  <a:schemeClr val="tx1"/>
+                </a:solidFill>
+              </a:rPr>
+              <a:t>查强活性化合物</a:t>
+            </a:r>
+            <a:endParaRPr lang="en-US" sz="1100" dirty="0"/>
+          </a:p>
+        </p:txBody>
+      </p:sp>
+      <p:sp>
+        <p:nvSpPr>
+          <p:cNvPr id="19" name="label-186"/>
+          <p:cNvSpPr txBox="1"/>
+          <p:nvPr/>
+        </p:nvSpPr>
+        <p:spPr>
+          <a:xfrm>
+            <a:off x="2423160" y="3941064"/>
+            <a:ext cx="1325880" cy="246888"/>
+          </a:xfrm>
+          <a:prstGeom prst="rect">
+            <a:avLst/>
+          </a:prstGeom>
+          <a:noFill/>
+          <a:ln/>
+        </p:spPr>
+        <p:txBody>
+          <a:bodyPr wrap="square" lIns="0" tIns="0" rIns="0" bIns="0" rtlCol="0" anchor="ctr"/>
+          <a:lstStyle/>
+          <a:p>
+            <a:pPr algn="ctr" indent="0" marL="0">
+              <a:buNone/>
+            </a:pPr>
+            <a:r>
+              <a:rPr lang="en-US" sz="1100" dirty="0">
+                <a:solidFill>
+                  <a:schemeClr val="tx1"/>
+                </a:solidFill>
+              </a:rPr>
+              <a:t>88% vs 81%</a:t>
+            </a:r>
+            <a:endParaRPr lang="en-US" sz="1100" dirty="0"/>
+          </a:p>
+        </p:txBody>
+      </p:sp>
+      <p:sp>
+        <p:nvSpPr>
+          <p:cNvPr id="20" name="bar-187"/>
+          <p:cNvSpPr/>
+          <p:nvPr/>
+        </p:nvSpPr>
+        <p:spPr>
+          <a:xfrm>
+            <a:off x="3749040" y="3986784"/>
+            <a:ext cx="443132" cy="155448"/>
+          </a:xfrm>
+          <a:prstGeom prst="rect">
+            <a:avLst/>
+          </a:prstGeom>
+          <a:solidFill>
+            <a:srgbClr val="B4BFCC"/>
+          </a:solidFill>
+          <a:ln w="12700">
+            <a:solidFill>
+              <a:srgbClr val="B4BFCC"/>
+            </a:solidFill>
+            <a:prstDash val="solid"/>
+          </a:ln>
+        </p:spPr>
+      </p:sp>
+      <p:sp>
+        <p:nvSpPr>
+          <p:cNvPr id="21" name="label-188"/>
+          <p:cNvSpPr txBox="1"/>
+          <p:nvPr/>
+        </p:nvSpPr>
+        <p:spPr>
+          <a:xfrm>
+            <a:off x="4247036" y="3941064"/>
+            <a:ext cx="548640" cy="246888"/>
+          </a:xfrm>
+          <a:prstGeom prst="rect">
+            <a:avLst/>
+          </a:prstGeom>
+          <a:noFill/>
+          <a:ln/>
+        </p:spPr>
+        <p:txBody>
+          <a:bodyPr wrap="square" lIns="0" tIns="0" rIns="0" bIns="0" rtlCol="0" anchor="ctr"/>
+          <a:lstStyle/>
+          <a:p>
+            <a:pPr algn="l" indent="0" marL="0">
+              <a:buNone/>
+            </a:pPr>
+            <a:r>
+              <a:rPr lang="en-US" sz="1050" b="1" dirty="0">
+                <a:solidFill>
+                  <a:schemeClr val="tx1"/>
+                </a:solidFill>
+              </a:rPr>
+              <a:t>0.006</a:t>
+            </a:r>
+            <a:endParaRPr lang="en-US" sz="1050" dirty="0"/>
+          </a:p>
+        </p:txBody>
+      </p:sp>
+      <p:sp>
+        <p:nvSpPr>
+          <p:cNvPr id="22" name="label-189"/>
+          <p:cNvSpPr txBox="1"/>
+          <p:nvPr/>
+        </p:nvSpPr>
+        <p:spPr>
+          <a:xfrm>
+            <a:off x="822960" y="4242816"/>
+            <a:ext cx="6355080" cy="237744"/>
+          </a:xfrm>
+          <a:prstGeom prst="rect">
+            <a:avLst/>
+          </a:prstGeom>
+          <a:noFill/>
+          <a:ln/>
+        </p:spPr>
+        <p:txBody>
+          <a:bodyPr wrap="square" lIns="0" tIns="0" rIns="0" bIns="0" rtlCol="0" anchor="t"/>
+          <a:lstStyle/>
+          <a:p>
+            <a:pPr algn="l" indent="0" marL="0">
+              <a:buNone/>
+            </a:pPr>
+            <a:r>
               <a:rPr lang="en-US" sz="1100" b="1" dirty="0">
                 <a:solidFill>
-                  <a:schemeClr val="tx2"/>
-                </a:solidFill>
-              </a:rPr>
-              <a:t>能分开多少</a:t>
+                  <a:schemeClr val="accent1"/>
+                </a:solidFill>
+              </a:rPr>
+              <a:t>看靶点与疾病的关系</a:t>
             </a:r>
             <a:endParaRPr lang="en-US" sz="1100" dirty="0"/>
           </a:p>
+        </p:txBody>
+      </p:sp>
+      <p:sp>
+        <p:nvSpPr>
+          <p:cNvPr id="23" name="label-190"/>
+          <p:cNvSpPr txBox="1"/>
+          <p:nvPr/>
+        </p:nvSpPr>
+        <p:spPr>
+          <a:xfrm>
+            <a:off x="960120" y="4489704"/>
+            <a:ext cx="1463040" cy="246888"/>
+          </a:xfrm>
+          <a:prstGeom prst="rect">
+            <a:avLst/>
+          </a:prstGeom>
+          <a:noFill/>
+          <a:ln/>
+        </p:spPr>
+        <p:txBody>
+          <a:bodyPr wrap="square" lIns="0" tIns="0" rIns="0" bIns="0" rtlCol="0" anchor="ctr"/>
+          <a:lstStyle/>
           <a:p>
             <a:pPr algn="l" indent="0" marL="0">
               <a:buNone/>
             </a:pPr>
             <a:r>
-              <a:rPr lang="en-US" sz="1100" b="1" dirty="0">
-                <a:solidFill>
-                  <a:schemeClr val="tx2"/>
-                </a:solidFill>
-              </a:rPr>
-              <a:t>（信息增益）</a:t>
+              <a:rPr lang="en-US" sz="1100" dirty="0">
+                <a:solidFill>
+                  <a:schemeClr val="tx1"/>
+                </a:solidFill>
+              </a:rPr>
+              <a:t>动物模型证据</a:t>
             </a:r>
             <a:endParaRPr lang="en-US" sz="1100" dirty="0"/>
           </a:p>
@@ -15152,14 +14752,50 @@
       </p:sp>
       <p:sp>
         <p:nvSpPr>
-          <p:cNvPr id="11" name="bar-178"/>
+          <p:cNvPr id="24" name="label-191"/>
+          <p:cNvSpPr txBox="1"/>
+          <p:nvPr/>
+        </p:nvSpPr>
+        <p:spPr>
+          <a:xfrm>
+            <a:off x="2423160" y="4489704"/>
+            <a:ext cx="1325880" cy="246888"/>
+          </a:xfrm>
+          <a:prstGeom prst="rect">
+            <a:avLst/>
+          </a:prstGeom>
+          <a:noFill/>
+          <a:ln/>
+        </p:spPr>
+        <p:txBody>
+          <a:bodyPr wrap="square" lIns="0" tIns="0" rIns="0" bIns="0" rtlCol="0" anchor="ctr"/>
+          <a:lstStyle/>
+          <a:p>
+            <a:pPr algn="ctr" indent="0" marL="0">
+              <a:buNone/>
+            </a:pPr>
+            <a:r>
+              <a:rPr lang="en-US" sz="1100" dirty="0">
+                <a:solidFill>
+                  <a:schemeClr val="tx1"/>
+                </a:solidFill>
+              </a:rPr>
+              <a:t>38% vs 17%</a:t>
+            </a:r>
+            <a:endParaRPr lang="en-US" sz="1100" dirty="0"/>
+          </a:p>
+        </p:txBody>
+      </p:sp>
+      <p:sp>
+        <p:nvSpPr>
+          <p:cNvPr id="25" name="bar-192"/>
           <p:cNvSpPr/>
           <p:nvPr/>
         </p:nvSpPr>
         <p:spPr>
           <a:xfrm>
-            <a:off x="4937760" y="3831336"/>
-            <a:ext cx="1737360" cy="201168"/>
+            <a:off x="3749040" y="4535424"/>
+            <a:ext cx="2880360" cy="155448"/>
           </a:xfrm>
           <a:prstGeom prst="rect">
             <a:avLst/>
@@ -15177,14 +14813,14 @@
       </p:sp>
       <p:sp>
         <p:nvSpPr>
-          <p:cNvPr id="12" name="label-179"/>
+          <p:cNvPr id="26" name="label-193"/>
           <p:cNvSpPr txBox="1"/>
           <p:nvPr/>
         </p:nvSpPr>
         <p:spPr>
           <a:xfrm>
-            <a:off x="6729984" y="3794760"/>
-            <a:ext cx="457200" cy="274320"/>
+            <a:off x="6684264" y="4489704"/>
+            <a:ext cx="548640" cy="246888"/>
           </a:xfrm>
           <a:prstGeom prst="rect">
             <a:avLst/>
@@ -15205,7 +14841,7 @@
                   <a:schemeClr val="tx1"/>
                 </a:solidFill>
               </a:rPr>
-              <a:t>0.26</a:t>
+              <a:t>0.039</a:t>
             </a:r>
             <a:endParaRPr lang="en-US" sz="1050" dirty="0"/>
           </a:p>
@@ -15213,14 +14849,14 @@
       </p:sp>
       <p:sp>
         <p:nvSpPr>
-          <p:cNvPr id="13" name="label-180"/>
+          <p:cNvPr id="27" name="label-194"/>
           <p:cNvSpPr txBox="1"/>
           <p:nvPr/>
         </p:nvSpPr>
         <p:spPr>
           <a:xfrm>
-            <a:off x="5010912" y="3794760"/>
-            <a:ext cx="1627632" cy="274320"/>
+            <a:off x="960120" y="4754880"/>
+            <a:ext cx="1463040" cy="246888"/>
           </a:xfrm>
           <a:prstGeom prst="rect">
             <a:avLst/>
@@ -15236,37 +14872,73 @@
               <a:buNone/>
             </a:pPr>
             <a:r>
-              <a:rPr lang="en-US" sz="1000" b="1" dirty="0">
-                <a:solidFill>
-                  <a:schemeClr val="bg1"/>
-                </a:solidFill>
-              </a:rPr>
-              <a:t>差别最大，先查</a:t>
-            </a:r>
-            <a:endParaRPr lang="en-US" sz="1000" dirty="0"/>
-          </a:p>
-        </p:txBody>
-      </p:sp>
-      <p:sp>
-        <p:nvSpPr>
-          <p:cNvPr id="14" name="bar-181"/>
+              <a:rPr lang="en-US" sz="1100" dirty="0">
+                <a:solidFill>
+                  <a:schemeClr val="tx1"/>
+                </a:solidFill>
+              </a:rPr>
+              <a:t>人类遗传学证据</a:t>
+            </a:r>
+            <a:endParaRPr lang="en-US" sz="1100" dirty="0"/>
+          </a:p>
+        </p:txBody>
+      </p:sp>
+      <p:sp>
+        <p:nvSpPr>
+          <p:cNvPr id="28" name="label-195"/>
+          <p:cNvSpPr txBox="1"/>
+          <p:nvPr/>
+        </p:nvSpPr>
+        <p:spPr>
+          <a:xfrm>
+            <a:off x="2423160" y="4754880"/>
+            <a:ext cx="1325880" cy="246888"/>
+          </a:xfrm>
+          <a:prstGeom prst="rect">
+            <a:avLst/>
+          </a:prstGeom>
+          <a:noFill/>
+          <a:ln/>
+        </p:spPr>
+        <p:txBody>
+          <a:bodyPr wrap="square" lIns="0" tIns="0" rIns="0" bIns="0" rtlCol="0" anchor="ctr"/>
+          <a:lstStyle/>
+          <a:p>
+            <a:pPr algn="ctr" indent="0" marL="0">
+              <a:buNone/>
+            </a:pPr>
+            <a:r>
+              <a:rPr lang="en-US" sz="1100" dirty="0">
+                <a:solidFill>
+                  <a:schemeClr val="tx1"/>
+                </a:solidFill>
+              </a:rPr>
+              <a:t>35% vs 17%</a:t>
+            </a:r>
+            <a:endParaRPr lang="en-US" sz="1100" dirty="0"/>
+          </a:p>
+        </p:txBody>
+      </p:sp>
+      <p:sp>
+        <p:nvSpPr>
+          <p:cNvPr id="29" name="bar-196"/>
           <p:cNvSpPr/>
           <p:nvPr/>
         </p:nvSpPr>
         <p:spPr>
           <a:xfrm>
-            <a:off x="4937760" y="4178808"/>
-            <a:ext cx="704335" cy="201168"/>
+            <a:off x="3749040" y="4800600"/>
+            <a:ext cx="1994095" cy="155448"/>
           </a:xfrm>
           <a:prstGeom prst="rect">
             <a:avLst/>
           </a:prstGeom>
           <a:solidFill>
-            <a:srgbClr val="8FC9C2"/>
+            <a:srgbClr val="0E8A7E"/>
           </a:solidFill>
           <a:ln w="12700">
             <a:solidFill>
-              <a:srgbClr val="8FC9C2"/>
+              <a:srgbClr val="0E8A7E"/>
             </a:solidFill>
             <a:prstDash val="solid"/>
           </a:ln>
@@ -15274,14 +14946,14 @@
       </p:sp>
       <p:sp>
         <p:nvSpPr>
-          <p:cNvPr id="15" name="label-182"/>
+          <p:cNvPr id="30" name="label-197"/>
           <p:cNvSpPr txBox="1"/>
           <p:nvPr/>
         </p:nvSpPr>
         <p:spPr>
           <a:xfrm>
-            <a:off x="5696959" y="4142232"/>
-            <a:ext cx="457200" cy="274320"/>
+            <a:off x="5797999" y="4754880"/>
+            <a:ext cx="548640" cy="246888"/>
           </a:xfrm>
           <a:prstGeom prst="rect">
             <a:avLst/>
@@ -15302,7 +14974,7 @@
                   <a:schemeClr val="tx1"/>
                 </a:solidFill>
               </a:rPr>
-              <a:t>0.11</a:t>
+              <a:t>0.027</a:t>
             </a:r>
             <a:endParaRPr lang="en-US" sz="1050" dirty="0"/>
           </a:p>
@@ -15310,39 +14982,58 @@
       </p:sp>
       <p:sp>
         <p:nvSpPr>
-          <p:cNvPr id="16" name="bar-183"/>
+          <p:cNvPr id="31" name="box-198"/>
           <p:cNvSpPr/>
           <p:nvPr/>
         </p:nvSpPr>
         <p:spPr>
           <a:xfrm>
-            <a:off x="4937760" y="4526280"/>
-            <a:ext cx="261610" cy="201168"/>
-          </a:xfrm>
-          <a:prstGeom prst="rect">
-            <a:avLst/>
+            <a:off x="822960" y="5093208"/>
+            <a:ext cx="6355080" cy="530352"/>
+          </a:xfrm>
+          <a:prstGeom prst="roundRect">
+            <a:avLst>
+              <a:gd name="adj" fmla="val 13793"/>
+            </a:avLst>
           </a:prstGeom>
           <a:solidFill>
-            <a:srgbClr val="8FC9C2"/>
+            <a:srgbClr val="E3F3F1"/>
           </a:solidFill>
           <a:ln w="12700">
             <a:solidFill>
-              <a:srgbClr val="8FC9C2"/>
+              <a:srgbClr val="0E8A7E"/>
             </a:solidFill>
-            <a:prstDash val="solid"/>
           </a:ln>
         </p:spPr>
-      </p:sp>
-      <p:sp>
-        <p:nvSpPr>
-          <p:cNvPr id="17" name="label-184"/>
+        <p:txBody>
+          <a:bodyPr wrap="square" lIns="1270" tIns="1270" rIns="1270" bIns="1270" rtlCol="0" anchor="ctr"/>
+          <a:lstStyle/>
+          <a:p>
+            <a:pPr algn="l" indent="0" marL="0">
+              <a:buNone/>
+            </a:pPr>
+            <a:r>
+              <a:rPr lang="en-US" sz="1100" dirty="0">
+                <a:solidFill>
+                  <a:schemeClr val="tx2"/>
+                </a:solidFill>
+              </a:rPr>
+              <a:t>结论：只看靶点本身分不出有效与否；靶点与疾病之间的证据才有区分力——与 Nature 2024 一致（有遗传学支持的药物机制，成功率高 2.6 倍）。</a:t>
+            </a:r>
+            <a:endParaRPr lang="en-US" sz="1100" dirty="0"/>
+          </a:p>
+        </p:txBody>
+      </p:sp>
+      <p:sp>
+        <p:nvSpPr>
+          <p:cNvPr id="32" name="label-199"/>
           <p:cNvSpPr txBox="1"/>
           <p:nvPr/>
         </p:nvSpPr>
         <p:spPr>
           <a:xfrm>
-            <a:off x="5254234" y="4489704"/>
-            <a:ext cx="457200" cy="274320"/>
+            <a:off x="822960" y="5696712"/>
+            <a:ext cx="6355080" cy="274320"/>
           </a:xfrm>
           <a:prstGeom prst="rect">
             <a:avLst/>
@@ -15351,7 +15042,7 @@
           <a:ln/>
         </p:spPr>
         <p:txBody>
-          <a:bodyPr wrap="square" lIns="0" tIns="0" rIns="0" bIns="0" rtlCol="0" anchor="ctr"/>
+          <a:bodyPr wrap="square" lIns="0" tIns="0" rIns="0" bIns="0" rtlCol="0" anchor="t"/>
           <a:lstStyle/>
           <a:p>
             <a:pPr algn="l" indent="0" marL="0">
@@ -15360,10 +15051,10 @@
             <a:r>
               <a:rPr lang="en-US" sz="1050" b="1" dirty="0">
                 <a:solidFill>
-                  <a:schemeClr val="tx1"/>
-                </a:solidFill>
-              </a:rPr>
-              <a:t>0.04</a:t>
+                  <a:schemeClr val="accent6"/>
+                </a:solidFill>
+              </a:rPr>
+              <a:t>普适性：方法通用，数字随问题类型而定——换一类问题，用该类已知答案的案例重测一次。</a:t>
             </a:r>
             <a:endParaRPr lang="en-US" sz="1050" dirty="0"/>
           </a:p>
@@ -15371,307 +15062,7 @@
       </p:sp>
       <p:sp>
         <p:nvSpPr>
-          <p:cNvPr id="18" name="label-185"/>
-          <p:cNvSpPr txBox="1"/>
-          <p:nvPr/>
-        </p:nvSpPr>
-        <p:spPr>
-          <a:xfrm>
-            <a:off x="5656570" y="4489704"/>
-            <a:ext cx="1521470" cy="274320"/>
-          </a:xfrm>
-          <a:prstGeom prst="rect">
-            <a:avLst/>
-          </a:prstGeom>
-          <a:noFill/>
-          <a:ln/>
-        </p:spPr>
-        <p:txBody>
-          <a:bodyPr wrap="square" lIns="0" tIns="0" rIns="0" bIns="0" rtlCol="0" anchor="ctr"/>
-          <a:lstStyle/>
-          <a:p>
-            <a:pPr algn="l" indent="0" marL="0">
-              <a:buNone/>
-            </a:pPr>
-            <a:r>
-              <a:rPr lang="en-US" sz="1000" dirty="0">
-                <a:solidFill>
-                  <a:schemeClr val="accent6"/>
-                </a:solidFill>
-              </a:rPr>
-              <a:t>像“量体温”</a:t>
-            </a:r>
-            <a:endParaRPr lang="en-US" sz="1000" dirty="0"/>
-          </a:p>
-        </p:txBody>
-      </p:sp>
-      <p:sp>
-        <p:nvSpPr>
-          <p:cNvPr id="19" name="label-186"/>
-          <p:cNvSpPr txBox="1"/>
-          <p:nvPr/>
-        </p:nvSpPr>
-        <p:spPr>
-          <a:xfrm>
-            <a:off x="822960" y="4956048"/>
-            <a:ext cx="6355080" cy="256032"/>
-          </a:xfrm>
-          <a:prstGeom prst="rect">
-            <a:avLst/>
-          </a:prstGeom>
-          <a:noFill/>
-          <a:ln/>
-        </p:spPr>
-        <p:txBody>
-          <a:bodyPr wrap="square" lIns="0" tIns="0" rIns="0" bIns="0" rtlCol="0" anchor="t"/>
-          <a:lstStyle/>
-          <a:p>
-            <a:pPr algn="l" indent="0" marL="0">
-              <a:buNone/>
-            </a:pPr>
-            <a:r>
-              <a:rPr lang="en-US" sz="1150" b="1" dirty="0">
-                <a:solidFill>
-                  <a:schemeClr val="tx2"/>
-                </a:solidFill>
-              </a:rPr>
-              <a:t>实际过程（分歧度：0 = 已有定论，1 = 五五开）</a:t>
-            </a:r>
-            <a:endParaRPr lang="en-US" sz="1150" dirty="0"/>
-          </a:p>
-        </p:txBody>
-      </p:sp>
-      <p:sp>
-        <p:nvSpPr>
-          <p:cNvPr id="20" name="badge-187"/>
-          <p:cNvSpPr/>
-          <p:nvPr/>
-        </p:nvSpPr>
-        <p:spPr>
-          <a:xfrm>
-            <a:off x="822960" y="5276088"/>
-            <a:ext cx="274320" cy="274320"/>
-          </a:xfrm>
-          <a:prstGeom prst="ellipse">
-            <a:avLst/>
-          </a:prstGeom>
-          <a:solidFill>
-            <a:schemeClr val="accent2"/>
-          </a:solidFill>
-          <a:ln w="6350">
-            <a:solidFill>
-              <a:schemeClr val="accent2"/>
-            </a:solidFill>
-          </a:ln>
-        </p:spPr>
-        <p:txBody>
-          <a:bodyPr wrap="square" lIns="0" tIns="0" rIns="0" bIns="0" rtlCol="0" anchor="ctr"/>
-          <a:lstStyle/>
-          <a:p>
-            <a:pPr algn="ctr" indent="0" marL="0">
-              <a:buNone/>
-            </a:pPr>
-            <a:r>
-              <a:rPr lang="en-US" sz="1200" b="1" dirty="0">
-                <a:solidFill>
-                  <a:schemeClr val="bg1"/>
-                </a:solidFill>
-              </a:rPr>
-              <a:t>1</a:t>
-            </a:r>
-            <a:endParaRPr lang="en-US" sz="1200" dirty="0"/>
-          </a:p>
-        </p:txBody>
-      </p:sp>
-      <p:sp>
-        <p:nvSpPr>
-          <p:cNvPr id="21" name="label-188"/>
-          <p:cNvSpPr txBox="1"/>
-          <p:nvPr/>
-        </p:nvSpPr>
-        <p:spPr>
-          <a:xfrm>
-            <a:off x="1207008" y="5248656"/>
-            <a:ext cx="3611880" cy="329184"/>
-          </a:xfrm>
-          <a:prstGeom prst="rect">
-            <a:avLst/>
-          </a:prstGeom>
-          <a:noFill/>
-          <a:ln/>
-        </p:spPr>
-        <p:txBody>
-          <a:bodyPr wrap="square" lIns="0" tIns="0" rIns="0" bIns="0" rtlCol="0" anchor="ctr"/>
-          <a:lstStyle/>
-          <a:p>
-            <a:pPr algn="l" indent="0" marL="0">
-              <a:buNone/>
-            </a:pPr>
-            <a:r>
-              <a:rPr lang="en-US" sz="1050" dirty="0">
-                <a:solidFill>
-                  <a:schemeClr val="tx1"/>
-                </a:solidFill>
-              </a:rPr>
-              <a:t>查到强活性：司美格鲁肽对 GLP-1 受体亲和力 0.38 nM</a:t>
-            </a:r>
-            <a:endParaRPr lang="en-US" sz="1050" dirty="0"/>
-          </a:p>
-        </p:txBody>
-      </p:sp>
-      <p:sp>
-        <p:nvSpPr>
-          <p:cNvPr id="22" name="label-189"/>
-          <p:cNvSpPr txBox="1"/>
-          <p:nvPr/>
-        </p:nvSpPr>
-        <p:spPr>
-          <a:xfrm>
-            <a:off x="4846320" y="5248656"/>
-            <a:ext cx="2331720" cy="329184"/>
-          </a:xfrm>
-          <a:prstGeom prst="rect">
-            <a:avLst/>
-          </a:prstGeom>
-          <a:noFill/>
-          <a:ln/>
-        </p:spPr>
-        <p:txBody>
-          <a:bodyPr wrap="square" lIns="0" tIns="0" rIns="0" bIns="0" rtlCol="0" anchor="ctr"/>
-          <a:lstStyle/>
-          <a:p>
-            <a:pPr algn="l" indent="0" marL="0">
-              <a:buNone/>
-            </a:pPr>
-            <a:r>
-              <a:rPr lang="en-US" sz="1050" b="1" dirty="0">
-                <a:solidFill>
-                  <a:schemeClr val="accent1"/>
-                </a:solidFill>
-              </a:rPr>
-              <a:t>支持概率 0.50 → 0.86</a:t>
-            </a:r>
-            <a:endParaRPr lang="en-US" sz="1050" dirty="0"/>
-          </a:p>
-        </p:txBody>
-      </p:sp>
-      <p:sp>
-        <p:nvSpPr>
-          <p:cNvPr id="23" name="badge-190"/>
-          <p:cNvSpPr/>
-          <p:nvPr/>
-        </p:nvSpPr>
-        <p:spPr>
-          <a:xfrm>
-            <a:off x="822960" y="5660136"/>
-            <a:ext cx="274320" cy="274320"/>
-          </a:xfrm>
-          <a:prstGeom prst="ellipse">
-            <a:avLst/>
-          </a:prstGeom>
-          <a:solidFill>
-            <a:schemeClr val="accent2"/>
-          </a:solidFill>
-          <a:ln w="6350">
-            <a:solidFill>
-              <a:schemeClr val="accent2"/>
-            </a:solidFill>
-          </a:ln>
-        </p:spPr>
-        <p:txBody>
-          <a:bodyPr wrap="square" lIns="0" tIns="0" rIns="0" bIns="0" rtlCol="0" anchor="ctr"/>
-          <a:lstStyle/>
-          <a:p>
-            <a:pPr algn="ctr" indent="0" marL="0">
-              <a:buNone/>
-            </a:pPr>
-            <a:r>
-              <a:rPr lang="en-US" sz="1200" b="1" dirty="0">
-                <a:solidFill>
-                  <a:schemeClr val="bg1"/>
-                </a:solidFill>
-              </a:rPr>
-              <a:t>2</a:t>
-            </a:r>
-            <a:endParaRPr lang="en-US" sz="1200" dirty="0"/>
-          </a:p>
-        </p:txBody>
-      </p:sp>
-      <p:sp>
-        <p:nvSpPr>
-          <p:cNvPr id="24" name="label-191"/>
-          <p:cNvSpPr txBox="1"/>
-          <p:nvPr/>
-        </p:nvSpPr>
-        <p:spPr>
-          <a:xfrm>
-            <a:off x="1207008" y="5632704"/>
-            <a:ext cx="3611880" cy="329184"/>
-          </a:xfrm>
-          <a:prstGeom prst="rect">
-            <a:avLst/>
-          </a:prstGeom>
-          <a:noFill/>
-          <a:ln/>
-        </p:spPr>
-        <p:txBody>
-          <a:bodyPr wrap="square" lIns="0" tIns="0" rIns="0" bIns="0" rtlCol="0" anchor="ctr"/>
-          <a:lstStyle/>
-          <a:p>
-            <a:pPr algn="l" indent="0" marL="0">
-              <a:buNone/>
-            </a:pPr>
-            <a:r>
-              <a:rPr lang="en-US" sz="1050" dirty="0">
-                <a:solidFill>
-                  <a:schemeClr val="tx1"/>
-                </a:solidFill>
-              </a:rPr>
-              <a:t>再查到三期试验 STEP 1（NCT03548935）</a:t>
-            </a:r>
-            <a:endParaRPr lang="en-US" sz="1050" dirty="0"/>
-          </a:p>
-        </p:txBody>
-      </p:sp>
-      <p:sp>
-        <p:nvSpPr>
-          <p:cNvPr id="25" name="label-192"/>
-          <p:cNvSpPr txBox="1"/>
-          <p:nvPr/>
-        </p:nvSpPr>
-        <p:spPr>
-          <a:xfrm>
-            <a:off x="4846320" y="5632704"/>
-            <a:ext cx="2331720" cy="329184"/>
-          </a:xfrm>
-          <a:prstGeom prst="rect">
-            <a:avLst/>
-          </a:prstGeom>
-          <a:noFill/>
-          <a:ln/>
-        </p:spPr>
-        <p:txBody>
-          <a:bodyPr wrap="square" lIns="0" tIns="0" rIns="0" bIns="0" rtlCol="0" anchor="ctr"/>
-          <a:lstStyle/>
-          <a:p>
-            <a:pPr algn="l" indent="0" marL="0">
-              <a:buNone/>
-            </a:pPr>
-            <a:r>
-              <a:rPr lang="en-US" sz="1050" b="1" dirty="0">
-                <a:solidFill>
-                  <a:schemeClr val="accent1"/>
-                </a:solidFill>
-              </a:rPr>
-              <a:t>0.86 → 0.95，分歧度 1.0 → 0.28</a:t>
-            </a:r>
-            <a:endParaRPr lang="en-US" sz="1050" dirty="0"/>
-          </a:p>
-        </p:txBody>
-      </p:sp>
-      <p:sp>
-        <p:nvSpPr>
-          <p:cNvPr id="26" name="card-193"/>
+          <p:cNvPr id="33" name="card-200"/>
           <p:cNvSpPr/>
           <p:nvPr/>
         </p:nvSpPr>
@@ -15698,7 +15089,7 @@
       </p:sp>
       <p:sp>
         <p:nvSpPr>
-          <p:cNvPr id="27" name="badge-194"/>
+          <p:cNvPr id="34" name="badge-201"/>
           <p:cNvSpPr/>
           <p:nvPr/>
         </p:nvSpPr>
@@ -15740,7 +15131,7 @@
       </p:sp>
       <p:sp>
         <p:nvSpPr>
-          <p:cNvPr id="28" name="label-195"/>
+          <p:cNvPr id="35" name="label-202"/>
           <p:cNvSpPr txBox="1"/>
           <p:nvPr/>
         </p:nvSpPr>
@@ -15776,7 +15167,7 @@
       </p:sp>
       <p:sp>
         <p:nvSpPr>
-          <p:cNvPr id="29" name="label-196"/>
+          <p:cNvPr id="36" name="label-203"/>
           <p:cNvSpPr txBox="1"/>
           <p:nvPr/>
         </p:nvSpPr>
@@ -15812,7 +15203,7 @@
       </p:sp>
       <p:sp>
         <p:nvSpPr>
-          <p:cNvPr id="30" name="label-197"/>
+          <p:cNvPr id="37" name="label-204"/>
           <p:cNvSpPr txBox="1"/>
           <p:nvPr/>
         </p:nvSpPr>
@@ -15848,7 +15239,7 @@
       </p:sp>
       <p:graphicFrame>
         <p:nvGraphicFramePr>
-          <p:cNvPr id="17" name="table-198"/>
+          <p:cNvPr id="9" name="table-205"/>
           <p:cNvGraphicFramePr>
             <a:graphicFrameLocks noGrp="1"/>
           </p:cNvGraphicFramePr>
@@ -16909,7 +16300,7 @@
       </p:graphicFrame>
       <p:sp>
         <p:nvSpPr>
-          <p:cNvPr id="32" name="label-199"/>
+          <p:cNvPr id="39" name="label-206"/>
           <p:cNvSpPr txBox="1"/>
           <p:nvPr/>
         </p:nvSpPr>
@@ -16945,7 +16336,7 @@
       </p:sp>
       <p:sp>
         <p:nvSpPr>
-          <p:cNvPr id="33" name="label-200"/>
+          <p:cNvPr id="40" name="label-207"/>
           <p:cNvSpPr txBox="1"/>
           <p:nvPr/>
         </p:nvSpPr>
@@ -16973,7 +16364,7 @@
                   <a:schemeClr val="accent6"/>
                 </a:solidFill>
               </a:rPr>
-              <a:t>说明：结果概率表目前为人工设定的先验，正式实验前需用标注数据估计（已提供估计函数）；专家意见作为起点的接口已实现，目前每个假设分支从 50 / 50 起步。</a:t>
+              <a:t>说明：靶点本身 114 例、靶点–疾病 94 例；动物模型差异 p = 0.023，遗传学 p = 0.062。系统目前仍按靶点查询，按“靶点–疾病”查询将在下一版接入。数据与脚本已存档，可复现。</a:t>
             </a:r>
             <a:endParaRPr lang="en-US" sz="1000" dirty="0"/>
           </a:p>
@@ -17127,7 +16518,7 @@
       </p:sp>
       <p:sp>
         <p:nvSpPr>
-          <p:cNvPr id="4" name="card-201"/>
+          <p:cNvPr id="4" name="card-208"/>
           <p:cNvSpPr/>
           <p:nvPr/>
         </p:nvSpPr>
@@ -17154,7 +16545,7 @@
       </p:sp>
       <p:sp>
         <p:nvSpPr>
-          <p:cNvPr id="5" name="tag-202"/>
+          <p:cNvPr id="5" name="tag-209"/>
           <p:cNvSpPr/>
           <p:nvPr/>
         </p:nvSpPr>
@@ -17198,7 +16589,7 @@
       </p:sp>
       <p:sp>
         <p:nvSpPr>
-          <p:cNvPr id="6" name="label-203"/>
+          <p:cNvPr id="6" name="label-210"/>
           <p:cNvSpPr txBox="1"/>
           <p:nvPr/>
         </p:nvSpPr>
@@ -17234,7 +16625,7 @@
       </p:sp>
       <p:sp>
         <p:nvSpPr>
-          <p:cNvPr id="7" name="box-204"/>
+          <p:cNvPr id="7" name="box-211"/>
           <p:cNvSpPr/>
           <p:nvPr/>
         </p:nvSpPr>
@@ -17278,7 +16669,7 @@
       </p:sp>
       <p:sp>
         <p:nvSpPr>
-          <p:cNvPr id="8" name="arrow-205"/>
+          <p:cNvPr id="8" name="arrow-212"/>
           <p:cNvSpPr/>
           <p:nvPr/>
         </p:nvSpPr>
@@ -17302,7 +16693,7 @@
       </p:sp>
       <p:sp>
         <p:nvSpPr>
-          <p:cNvPr id="9" name="box-206"/>
+          <p:cNvPr id="9" name="box-213"/>
           <p:cNvSpPr/>
           <p:nvPr/>
         </p:nvSpPr>
@@ -17346,7 +16737,7 @@
       </p:sp>
       <p:sp>
         <p:nvSpPr>
-          <p:cNvPr id="10" name="arrow-207"/>
+          <p:cNvPr id="10" name="arrow-214"/>
           <p:cNvSpPr/>
           <p:nvPr/>
         </p:nvSpPr>
@@ -17370,7 +16761,7 @@
       </p:sp>
       <p:sp>
         <p:nvSpPr>
-          <p:cNvPr id="11" name="box-208"/>
+          <p:cNvPr id="11" name="box-215"/>
           <p:cNvSpPr/>
           <p:nvPr/>
         </p:nvSpPr>
@@ -17414,7 +16805,7 @@
       </p:sp>
       <p:sp>
         <p:nvSpPr>
-          <p:cNvPr id="12" name="arrow-209"/>
+          <p:cNvPr id="12" name="arrow-216"/>
           <p:cNvSpPr/>
           <p:nvPr/>
         </p:nvSpPr>
@@ -17438,7 +16829,7 @@
       </p:sp>
       <p:sp>
         <p:nvSpPr>
-          <p:cNvPr id="13" name="box-210"/>
+          <p:cNvPr id="13" name="box-217"/>
           <p:cNvSpPr/>
           <p:nvPr/>
         </p:nvSpPr>
@@ -17482,7 +16873,7 @@
       </p:sp>
       <p:sp>
         <p:nvSpPr>
-          <p:cNvPr id="14" name="arrow-211"/>
+          <p:cNvPr id="14" name="arrow-218"/>
           <p:cNvSpPr/>
           <p:nvPr/>
         </p:nvSpPr>
@@ -17506,7 +16897,7 @@
       </p:sp>
       <p:sp>
         <p:nvSpPr>
-          <p:cNvPr id="15" name="box-212"/>
+          <p:cNvPr id="15" name="box-219"/>
           <p:cNvSpPr/>
           <p:nvPr/>
         </p:nvSpPr>
@@ -17550,7 +16941,7 @@
       </p:sp>
       <p:sp>
         <p:nvSpPr>
-          <p:cNvPr id="16" name="bullets-213"/>
+          <p:cNvPr id="16" name="bullets-220"/>
           <p:cNvSpPr txBox="1"/>
           <p:nvPr/>
         </p:nvSpPr>
@@ -17626,7 +17017,7 @@
       </p:sp>
       <p:sp>
         <p:nvSpPr>
-          <p:cNvPr id="17" name="label-214"/>
+          <p:cNvPr id="17" name="label-221"/>
           <p:cNvSpPr txBox="1"/>
           <p:nvPr/>
         </p:nvSpPr>
@@ -17662,7 +17053,7 @@
       </p:sp>
       <p:sp>
         <p:nvSpPr>
-          <p:cNvPr id="18" name="label-215"/>
+          <p:cNvPr id="18" name="label-222"/>
           <p:cNvSpPr txBox="1"/>
           <p:nvPr/>
         </p:nvSpPr>
@@ -17698,7 +17089,7 @@
       </p:sp>
       <p:sp>
         <p:nvSpPr>
-          <p:cNvPr id="19" name="label-216"/>
+          <p:cNvPr id="19" name="label-223"/>
           <p:cNvSpPr txBox="1"/>
           <p:nvPr/>
         </p:nvSpPr>
@@ -17734,7 +17125,7 @@
       </p:sp>
       <p:sp>
         <p:nvSpPr>
-          <p:cNvPr id="20" name="label-217"/>
+          <p:cNvPr id="20" name="label-224"/>
           <p:cNvSpPr txBox="1"/>
           <p:nvPr/>
         </p:nvSpPr>
@@ -17770,7 +17161,7 @@
       </p:sp>
       <p:sp>
         <p:nvSpPr>
-          <p:cNvPr id="21" name="label-218"/>
+          <p:cNvPr id="21" name="label-225"/>
           <p:cNvSpPr txBox="1"/>
           <p:nvPr/>
         </p:nvSpPr>
@@ -17806,7 +17197,7 @@
       </p:sp>
       <p:sp>
         <p:nvSpPr>
-          <p:cNvPr id="22" name="label-219"/>
+          <p:cNvPr id="22" name="label-226"/>
           <p:cNvSpPr txBox="1"/>
           <p:nvPr/>
         </p:nvSpPr>
@@ -17842,7 +17233,7 @@
       </p:sp>
       <p:sp>
         <p:nvSpPr>
-          <p:cNvPr id="23" name="card-220"/>
+          <p:cNvPr id="23" name="card-227"/>
           <p:cNvSpPr/>
           <p:nvPr/>
         </p:nvSpPr>
@@ -17869,7 +17260,7 @@
       </p:sp>
       <p:sp>
         <p:nvSpPr>
-          <p:cNvPr id="24" name="tag-221"/>
+          <p:cNvPr id="24" name="tag-228"/>
           <p:cNvSpPr/>
           <p:nvPr/>
         </p:nvSpPr>
@@ -17913,7 +17304,7 @@
       </p:sp>
       <p:sp>
         <p:nvSpPr>
-          <p:cNvPr id="25" name="label-222"/>
+          <p:cNvPr id="25" name="label-229"/>
           <p:cNvSpPr txBox="1"/>
           <p:nvPr/>
         </p:nvSpPr>
@@ -17949,7 +17340,7 @@
       </p:sp>
       <p:sp>
         <p:nvSpPr>
-          <p:cNvPr id="26" name="box-223"/>
+          <p:cNvPr id="26" name="box-230"/>
           <p:cNvSpPr/>
           <p:nvPr/>
         </p:nvSpPr>
@@ -17993,7 +17384,7 @@
       </p:sp>
       <p:sp>
         <p:nvSpPr>
-          <p:cNvPr id="27" name="arrow-224"/>
+          <p:cNvPr id="27" name="arrow-231"/>
           <p:cNvSpPr/>
           <p:nvPr/>
         </p:nvSpPr>
@@ -18017,7 +17408,7 @@
       </p:sp>
       <p:sp>
         <p:nvSpPr>
-          <p:cNvPr id="28" name="box-225"/>
+          <p:cNvPr id="28" name="box-232"/>
           <p:cNvSpPr/>
           <p:nvPr/>
         </p:nvSpPr>
@@ -18061,7 +17452,7 @@
       </p:sp>
       <p:sp>
         <p:nvSpPr>
-          <p:cNvPr id="29" name="arrow-226"/>
+          <p:cNvPr id="29" name="arrow-233"/>
           <p:cNvSpPr/>
           <p:nvPr/>
         </p:nvSpPr>
@@ -18085,7 +17476,7 @@
       </p:sp>
       <p:sp>
         <p:nvSpPr>
-          <p:cNvPr id="30" name="arrow-227"/>
+          <p:cNvPr id="30" name="arrow-234"/>
           <p:cNvSpPr/>
           <p:nvPr/>
         </p:nvSpPr>
@@ -18109,7 +17500,7 @@
       </p:sp>
       <p:sp>
         <p:nvSpPr>
-          <p:cNvPr id="31" name="box-228"/>
+          <p:cNvPr id="31" name="box-235"/>
           <p:cNvSpPr/>
           <p:nvPr/>
         </p:nvSpPr>
@@ -18153,7 +17544,7 @@
       </p:sp>
       <p:sp>
         <p:nvSpPr>
-          <p:cNvPr id="32" name="box-229"/>
+          <p:cNvPr id="32" name="box-236"/>
           <p:cNvSpPr/>
           <p:nvPr/>
         </p:nvSpPr>
@@ -18197,7 +17588,7 @@
       </p:sp>
       <p:sp>
         <p:nvSpPr>
-          <p:cNvPr id="33" name="bullets-230"/>
+          <p:cNvPr id="33" name="bullets-237"/>
           <p:cNvSpPr txBox="1"/>
           <p:nvPr/>
         </p:nvSpPr>
@@ -18273,7 +17664,7 @@
       </p:sp>
       <p:sp>
         <p:nvSpPr>
-          <p:cNvPr id="34" name="label-231"/>
+          <p:cNvPr id="34" name="label-238"/>
           <p:cNvSpPr txBox="1"/>
           <p:nvPr/>
         </p:nvSpPr>

</xml_diff>